<commit_message>
docs: add AI workflow slides to defense deck
Co-Authored-By: Claude Opus 5.5 (1M context) <noreply@anthropic.com>
</commit_message>
<xml_diff>
--- a/docs/Event-Tickets-API-Defense.pptx
+++ b/docs/Event-Tickets-API-Defense.pptx
@@ -19,9 +19,11 @@
     <p:sldId id="267" r:id="rId13"/>
     <p:sldId id="268" r:id="rId14"/>
     <p:sldId id="269" r:id="rId15"/>
+    <p:sldId id="270" r:id="rId16"/>
+    <p:sldId id="271" r:id="rId17"/>
   </p:sldIdLst>
   <p:notesMasterIdLst>
-    <p:notesMasterId r:id="rId16"/>
+    <p:notesMasterId r:id="rId18"/>
   </p:notesMasterIdLst>
   <p:sldSz cx="12192000" cy="6858000"/>
   <p:notesSz cx="6858000" cy="12192000"/>
@@ -779,7 +781,7 @@
           <a:p>
             <a:r>
               <a:rPr lang="en-US" dirty="0"/>
-              <a:t>សរុបមក ខ្ញុំរៀនបាន ៣ យ៉ាង។ ទីមួយ កុំជឿ client — តម្លៃ និងអត្តសញ្ញាណ ត្រូវមកពី server។ ទីពីរ ពិនិត្យ និងសរសេរ ត្រូវតែជាជំហានតែមួយ បើមិនដូច្នេះ អ្នកប្រើច្រើននាក់ អាចលក់លើសកៅអី។ ទីបី transaction ធ្វើឲ្យការផ្លាស់ប្តូរច្រើន ជោគជ័យទាំងអស់ ឬត្រឡប់វិញទាំងអស់។</a:t>
+              <a:t>ខ្ញុំប្រើ Claude Code ជាជំនួយការ។ ដំណើរការគឺ spec មុន កូដក្រោយ។ ខ្ញុំផ្តល់ homework និងច្បាប់ទាំង ៦ ហើយ AI សរសេរ DESIGN.md ជាមុនសិន។ ខ្ញុំ review design នោះ មុនពេលសរសេរកូដណាមួយ។ បន្ទាប់មក AI សរសេរកូដ និង tests តាម design។ ចុងក្រោយ ខ្ញុំរត់ tests ខ្លួនឯង ហើយមើល diff មុន commit។</a:t>
             </a:r>
             <a:endParaRPr lang="en-US" dirty="0"/>
           </a:p>
@@ -867,7 +869,7 @@
           <a:p>
             <a:r>
               <a:rPr lang="en-US" dirty="0"/>
-              <a:t>ឥឡូវ ខ្ញុំនឹងបង្ហាញផ្ទាល់។ ទីមួយ alice ផ្ញើ price 0.01 — server មិនអើពើ ហើយគិត 50.00។ ទីពីរ កក់ event ដែលបានបោះបង់ → 409។ ទីបី quantity 5 → 400។ ទីបួន bob មើល booking របស់ alice → 403។</a:t>
+              <a:t>AI សរសេរលឿន ប៉ុន្តែខ្ញុំទទួលខុសត្រូវ លើភាពត្រឹមត្រូវ។ Claude Code សរសេរ design, កូដ, tests និងឯកសារ។ ខ្ញុំផ្តល់ requirement, review design និង diff, រត់ tests ទាំង 20 ឲ្យជាប់ ហើយសម្រេចចិត្ត commit និង merge។ គ្រប់ commit ក្នុង git មាន Co-Authored-By: Claude ដូច្នេះការប្រើ AI មានតម្លាភាព។</a:t>
             </a:r>
             <a:endParaRPr lang="en-US" dirty="0"/>
           </a:p>
@@ -955,7 +957,7 @@
           <a:p>
             <a:r>
               <a:rPr lang="en-US" dirty="0"/>
-              <a:t>សូមអរគុណ ចំពោះការស្តាប់។ សំណួរដែលអាចមាន៖ ហេតុអ្វីមិនប្រើ synchronized? — ព្រោះវាដំណើរការតែក្នុង server មួយ ចំណែក database lock ដំណើរការ ទោះមាន server ច្រើន។ ហេតុអ្វីមិនប្រើ optimistic lock (@Version)? — វាក៏អាចប្រើបាន ប៉ុន្តែត្រូវ retry ពេល conflict ចំណែក conditional UPDATE សាមញ្ញជាង។</a:t>
+              <a:t>សរុបមក ខ្ញុំរៀនបាន ៣ យ៉ាង។ ទីមួយ កុំជឿ client — តម្លៃ និងអត្តសញ្ញាណ ត្រូវមកពី server។ ទីពីរ ពិនិត្យ និងសរសេរ ត្រូវតែជាជំហានតែមួយ បើមិនដូច្នេះ អ្នកប្រើច្រើននាក់ អាចលក់លើសកៅអី។ ទីបី transaction ធ្វើឲ្យការផ្លាស់ប្តូរច្រើន ជោគជ័យទាំងអស់ ឬត្រឡប់វិញទាំងអស់។</a:t>
             </a:r>
             <a:endParaRPr lang="en-US" dirty="0"/>
           </a:p>
@@ -979,6 +981,182 @@
             <a:fld id="{F7021451-1387-4CA6-816F-3879F97B5CBC}" type="slidenum">
               <a:rPr lang="en-US"/>
               <a:t>14</a:t>
+            </a:fld>
+            <a:endParaRPr lang="en-US"/>
+          </a:p>
+        </p:txBody>
+      </p:sp>
+    </p:spTree>
+    <p:extLst>
+      <p:ext uri="{BB962C8B-B14F-4D97-AF65-F5344CB8AC3E}">
+        <p14:creationId xmlns:p14="http://schemas.microsoft.com/office/powerpoint/2010/main" val="1024086991"/>
+      </p:ext>
+    </p:extLst>
+  </p:cSld>
+  <p:clrMapOvr>
+    <a:masterClrMapping/>
+  </p:clrMapOvr>
+</p:notes>
+</file>
+
+<file path=ppt/notesSlides/notesSlide15.xml><?xml version="1.0" encoding="utf-8"?>
+<p:notes xmlns:a="http://schemas.openxmlformats.org/drawingml/2006/main" xmlns:r="http://schemas.openxmlformats.org/officeDocument/2006/relationships" xmlns:p="http://schemas.openxmlformats.org/presentationml/2006/main">
+  <p:cSld>
+    <p:spTree>
+      <p:nvGrpSpPr>
+        <p:cNvPr id="1" name=""/>
+        <p:cNvGrpSpPr/>
+        <p:nvPr/>
+      </p:nvGrpSpPr>
+      <p:grpSpPr>
+        <a:xfrm>
+          <a:off x="0" y="0"/>
+          <a:ext cx="0" cy="0"/>
+          <a:chOff x="0" y="0"/>
+          <a:chExt cx="0" cy="0"/>
+        </a:xfrm>
+      </p:grpSpPr>
+      <p:sp>
+        <p:nvSpPr>
+          <p:cNvPr id="2" name="Slide Image Placeholder 1"/>
+          <p:cNvSpPr>
+            <a:spLocks noGrp="1" noRot="1" noChangeAspect="1"/>
+          </p:cNvSpPr>
+          <p:nvPr>
+            <p:ph type="sldImg"/>
+          </p:nvPr>
+        </p:nvSpPr>
+        <p:spPr/>
+      </p:sp>
+      <p:sp>
+        <p:nvSpPr>
+          <p:cNvPr id="3" name="Notes Placeholder 2"/>
+          <p:cNvSpPr>
+            <a:spLocks noGrp="1"/>
+          </p:cNvSpPr>
+          <p:nvPr>
+            <p:ph type="body" idx="1"/>
+          </p:nvPr>
+        </p:nvSpPr>
+        <p:spPr/>
+        <p:txBody>
+          <a:bodyPr/>
+          <a:lstStyle/>
+          <a:p>
+            <a:r>
+              <a:rPr lang="en-US" dirty="0"/>
+              <a:t>ឥឡូវ ខ្ញុំនឹងបង្ហាញផ្ទាល់។ ទីមួយ alice ផ្ញើ price 0.01 — server មិនអើពើ ហើយគិត 50.00។ ទីពីរ កក់ event ដែលបានបោះបង់ → 409។ ទីបី quantity 5 → 400។ ទីបួន bob មើល booking របស់ alice → 403។</a:t>
+            </a:r>
+            <a:endParaRPr lang="en-US" dirty="0"/>
+          </a:p>
+        </p:txBody>
+      </p:sp>
+      <p:sp>
+        <p:nvSpPr>
+          <p:cNvPr id="4" name="Slide Number Placeholder 3"/>
+          <p:cNvSpPr>
+            <a:spLocks noGrp="1"/>
+          </p:cNvSpPr>
+          <p:nvPr>
+            <p:ph type="sldNum" sz="quarter" idx="10"/>
+          </p:nvPr>
+        </p:nvSpPr>
+        <p:spPr/>
+        <p:txBody>
+          <a:bodyPr/>
+          <a:lstStyle/>
+          <a:p>
+            <a:fld id="{F7021451-1387-4CA6-816F-3879F97B5CBC}" type="slidenum">
+              <a:rPr lang="en-US"/>
+              <a:t>15</a:t>
+            </a:fld>
+            <a:endParaRPr lang="en-US"/>
+          </a:p>
+        </p:txBody>
+      </p:sp>
+    </p:spTree>
+    <p:extLst>
+      <p:ext uri="{BB962C8B-B14F-4D97-AF65-F5344CB8AC3E}">
+        <p14:creationId xmlns:p14="http://schemas.microsoft.com/office/powerpoint/2010/main" val="1024086991"/>
+      </p:ext>
+    </p:extLst>
+  </p:cSld>
+  <p:clrMapOvr>
+    <a:masterClrMapping/>
+  </p:clrMapOvr>
+</p:notes>
+</file>
+
+<file path=ppt/notesSlides/notesSlide16.xml><?xml version="1.0" encoding="utf-8"?>
+<p:notes xmlns:a="http://schemas.openxmlformats.org/drawingml/2006/main" xmlns:r="http://schemas.openxmlformats.org/officeDocument/2006/relationships" xmlns:p="http://schemas.openxmlformats.org/presentationml/2006/main">
+  <p:cSld>
+    <p:spTree>
+      <p:nvGrpSpPr>
+        <p:cNvPr id="1" name=""/>
+        <p:cNvGrpSpPr/>
+        <p:nvPr/>
+      </p:nvGrpSpPr>
+      <p:grpSpPr>
+        <a:xfrm>
+          <a:off x="0" y="0"/>
+          <a:ext cx="0" cy="0"/>
+          <a:chOff x="0" y="0"/>
+          <a:chExt cx="0" cy="0"/>
+        </a:xfrm>
+      </p:grpSpPr>
+      <p:sp>
+        <p:nvSpPr>
+          <p:cNvPr id="2" name="Slide Image Placeholder 1"/>
+          <p:cNvSpPr>
+            <a:spLocks noGrp="1" noRot="1" noChangeAspect="1"/>
+          </p:cNvSpPr>
+          <p:nvPr>
+            <p:ph type="sldImg"/>
+          </p:nvPr>
+        </p:nvSpPr>
+        <p:spPr/>
+      </p:sp>
+      <p:sp>
+        <p:nvSpPr>
+          <p:cNvPr id="3" name="Notes Placeholder 2"/>
+          <p:cNvSpPr>
+            <a:spLocks noGrp="1"/>
+          </p:cNvSpPr>
+          <p:nvPr>
+            <p:ph type="body" idx="1"/>
+          </p:nvPr>
+        </p:nvSpPr>
+        <p:spPr/>
+        <p:txBody>
+          <a:bodyPr/>
+          <a:lstStyle/>
+          <a:p>
+            <a:r>
+              <a:rPr lang="en-US" dirty="0"/>
+              <a:t>សូមអរគុណ ចំពោះការស្តាប់។ សំណួរដែលអាចមាន៖ ហេតុអ្វីមិនប្រើ synchronized? — ព្រោះវាដំណើរការតែក្នុង server មួយ ចំណែក database lock ដំណើរការ ទោះមាន server ច្រើន។ ហេតុអ្វីមិនប្រើ optimistic lock (@Version)? — វាក៏អាចប្រើបាន ប៉ុន្តែត្រូវ retry ពេល conflict ចំណែក conditional UPDATE សាមញ្ញជាង។</a:t>
+            </a:r>
+            <a:endParaRPr lang="en-US" dirty="0"/>
+          </a:p>
+        </p:txBody>
+      </p:sp>
+      <p:sp>
+        <p:nvSpPr>
+          <p:cNvPr id="4" name="Slide Number Placeholder 3"/>
+          <p:cNvSpPr>
+            <a:spLocks noGrp="1"/>
+          </p:cNvSpPr>
+          <p:nvPr>
+            <p:ph type="sldNum" sz="quarter" idx="10"/>
+          </p:nvPr>
+        </p:nvSpPr>
+        <p:spPr/>
+        <p:txBody>
+          <a:bodyPr/>
+          <a:lstStyle/>
+          <a:p>
+            <a:fld id="{F7021451-1387-4CA6-816F-3879F97B5CBC}" type="slidenum">
+              <a:rPr lang="en-US"/>
+              <a:t>16</a:t>
             </a:fld>
             <a:endParaRPr lang="en-US"/>
           </a:p>
@@ -2040,8 +2218,8 @@
         </p:nvSpPr>
         <p:spPr>
           <a:xfrm>
-            <a:off x="812800" y="2123440"/>
-            <a:ext cx="10883392" cy="238760"/>
+            <a:off x="812800" y="2123480"/>
+            <a:ext cx="10883392" cy="238720"/>
           </a:xfrm>
           <a:prstGeom prst="rect">
             <a:avLst/>
@@ -2173,7 +2351,7 @@
         <p:spPr>
           <a:xfrm>
             <a:off x="812800" y="4165600"/>
-            <a:ext cx="1676400" cy="365760"/>
+            <a:ext cx="1676400" cy="365720"/>
           </a:xfrm>
           <a:prstGeom prst="roundRect">
             <a:avLst>
@@ -2195,7 +2373,7 @@
         <p:spPr>
           <a:xfrm>
             <a:off x="965200" y="4241800"/>
-            <a:ext cx="1422400" cy="238760"/>
+            <a:ext cx="1422400" cy="238720"/>
           </a:xfrm>
           <a:prstGeom prst="rect">
             <a:avLst/>
@@ -2239,7 +2417,7 @@
         <p:spPr>
           <a:xfrm>
             <a:off x="2590800" y="4165600"/>
-            <a:ext cx="944880" cy="365760"/>
+            <a:ext cx="944910" cy="365720"/>
           </a:xfrm>
           <a:prstGeom prst="roundRect">
             <a:avLst>
@@ -2261,7 +2439,7 @@
         <p:spPr>
           <a:xfrm>
             <a:off x="2743200" y="4241800"/>
-            <a:ext cx="690880" cy="238760"/>
+            <a:ext cx="690910" cy="238720"/>
           </a:xfrm>
           <a:prstGeom prst="rect">
             <a:avLst/>
@@ -2304,8 +2482,8 @@
         </p:nvSpPr>
         <p:spPr>
           <a:xfrm>
-            <a:off x="3637280" y="4165600"/>
-            <a:ext cx="853440" cy="365760"/>
+            <a:off x="3637310" y="4165600"/>
+            <a:ext cx="853480" cy="365720"/>
           </a:xfrm>
           <a:prstGeom prst="roundRect">
             <a:avLst>
@@ -2326,8 +2504,8 @@
         </p:nvSpPr>
         <p:spPr>
           <a:xfrm>
-            <a:off x="3789680" y="4241800"/>
-            <a:ext cx="599440" cy="238760"/>
+            <a:off x="3789710" y="4241800"/>
+            <a:ext cx="599480" cy="238720"/>
           </a:xfrm>
           <a:prstGeom prst="rect">
             <a:avLst/>
@@ -2370,8 +2548,8 @@
         </p:nvSpPr>
         <p:spPr>
           <a:xfrm>
-            <a:off x="4592320" y="4165600"/>
-            <a:ext cx="1036320" cy="365760"/>
+            <a:off x="4592389" y="4165600"/>
+            <a:ext cx="1036340" cy="365720"/>
           </a:xfrm>
           <a:prstGeom prst="roundRect">
             <a:avLst>
@@ -2392,8 +2570,8 @@
         </p:nvSpPr>
         <p:spPr>
           <a:xfrm>
-            <a:off x="4744720" y="4241800"/>
-            <a:ext cx="782320" cy="238760"/>
+            <a:off x="4744789" y="4241800"/>
+            <a:ext cx="782340" cy="238720"/>
           </a:xfrm>
           <a:prstGeom prst="rect">
             <a:avLst/>
@@ -2436,8 +2614,8 @@
         </p:nvSpPr>
         <p:spPr>
           <a:xfrm>
-            <a:off x="812800" y="6238240"/>
-            <a:ext cx="10883392" cy="238760"/>
+            <a:off x="812800" y="6238280"/>
+            <a:ext cx="10883392" cy="238720"/>
           </a:xfrm>
           <a:prstGeom prst="rect">
             <a:avLst/>
@@ -2513,7 +2691,7 @@
         <p:spPr>
           <a:xfrm>
             <a:off x="812800" y="812800"/>
-            <a:ext cx="10883392" cy="238760"/>
+            <a:ext cx="10883392" cy="238720"/>
           </a:xfrm>
           <a:prstGeom prst="rect">
             <a:avLst/>
@@ -2556,8 +2734,8 @@
         </p:nvSpPr>
         <p:spPr>
           <a:xfrm>
-            <a:off x="812800" y="1102364"/>
-            <a:ext cx="10883392" cy="553720"/>
+            <a:off x="812800" y="1102320"/>
+            <a:ext cx="10883392" cy="553690"/>
           </a:xfrm>
           <a:prstGeom prst="rect">
             <a:avLst/>
@@ -2600,7 +2778,7 @@
         </p:nvSpPr>
         <p:spPr>
           <a:xfrm>
-            <a:off x="812800" y="1935479"/>
+            <a:off x="812800" y="1935411"/>
             <a:ext cx="5284724" cy="355600"/>
           </a:xfrm>
           <a:prstGeom prst="rect">
@@ -2644,7 +2822,7 @@
         </p:nvSpPr>
         <p:spPr>
           <a:xfrm>
-            <a:off x="812800" y="2418079"/>
+            <a:off x="812800" y="2418011"/>
             <a:ext cx="5284724" cy="311150"/>
           </a:xfrm>
           <a:prstGeom prst="rect">
@@ -2688,7 +2866,7 @@
         </p:nvSpPr>
         <p:spPr>
           <a:xfrm>
-            <a:off x="812800" y="2856229"/>
+            <a:off x="812800" y="2856161"/>
             <a:ext cx="5130800" cy="1739900"/>
           </a:xfrm>
           <a:prstGeom prst="roundRect">
@@ -2710,7 +2888,7 @@
         </p:nvSpPr>
         <p:spPr>
           <a:xfrm>
-            <a:off x="1016000" y="3059429"/>
+            <a:off x="1016000" y="3059361"/>
             <a:ext cx="4866132" cy="1358900"/>
           </a:xfrm>
           <a:prstGeom prst="rect">
@@ -2834,7 +3012,7 @@
         </p:nvSpPr>
         <p:spPr>
           <a:xfrm>
-            <a:off x="6248400" y="1935479"/>
+            <a:off x="6248400" y="1935411"/>
             <a:ext cx="5284724" cy="355600"/>
           </a:xfrm>
           <a:prstGeom prst="rect">
@@ -2878,12 +3056,12 @@
         </p:nvSpPr>
         <p:spPr>
           <a:xfrm>
-            <a:off x="6251575" y="2421254"/>
-            <a:ext cx="5124450" cy="1000760"/>
+            <a:off x="6251575" y="2421186"/>
+            <a:ext cx="5124450" cy="1003300"/>
           </a:xfrm>
           <a:prstGeom prst="roundRect">
             <a:avLst>
-              <a:gd name="adj" fmla="val 9835"/>
+              <a:gd name="adj" fmla="val 9810"/>
             </a:avLst>
           </a:prstGeom>
           <a:solidFill>
@@ -2905,8 +3083,8 @@
         </p:nvSpPr>
         <p:spPr>
           <a:xfrm>
-            <a:off x="6456680" y="2626364"/>
-            <a:ext cx="4855667" cy="311150"/>
+            <a:off x="6457950" y="2627561"/>
+            <a:ext cx="4853051" cy="311150"/>
           </a:xfrm>
           <a:prstGeom prst="rect">
             <a:avLst/>
@@ -2960,8 +3138,8 @@
         </p:nvSpPr>
         <p:spPr>
           <a:xfrm>
-            <a:off x="6456680" y="2988314"/>
-            <a:ext cx="4855667" cy="254000"/>
+            <a:off x="6457950" y="2989511"/>
+            <a:ext cx="4853051" cy="254000"/>
           </a:xfrm>
           <a:prstGeom prst="rect">
             <a:avLst/>
@@ -3004,12 +3182,12 @@
         </p:nvSpPr>
         <p:spPr>
           <a:xfrm>
-            <a:off x="6251575" y="3580767"/>
-            <a:ext cx="5124450" cy="1000760"/>
+            <a:off x="6251575" y="3583236"/>
+            <a:ext cx="5124450" cy="1003300"/>
           </a:xfrm>
           <a:prstGeom prst="roundRect">
             <a:avLst>
-              <a:gd name="adj" fmla="val 9835"/>
+              <a:gd name="adj" fmla="val 9810"/>
             </a:avLst>
           </a:prstGeom>
           <a:solidFill>
@@ -3031,8 +3209,8 @@
         </p:nvSpPr>
         <p:spPr>
           <a:xfrm>
-            <a:off x="6456680" y="3785871"/>
-            <a:ext cx="4855667" cy="311150"/>
+            <a:off x="6457950" y="3789611"/>
+            <a:ext cx="4853051" cy="311150"/>
           </a:xfrm>
           <a:prstGeom prst="rect">
             <a:avLst/>
@@ -3086,8 +3264,8 @@
         </p:nvSpPr>
         <p:spPr>
           <a:xfrm>
-            <a:off x="6456680" y="4147821"/>
-            <a:ext cx="4855667" cy="254000"/>
+            <a:off x="6457950" y="4151561"/>
+            <a:ext cx="4853051" cy="254000"/>
           </a:xfrm>
           <a:prstGeom prst="rect">
             <a:avLst/>
@@ -3130,7 +3308,7 @@
         </p:nvSpPr>
         <p:spPr>
           <a:xfrm>
-            <a:off x="6248400" y="4737100"/>
+            <a:off x="6248400" y="4742111"/>
             <a:ext cx="5284724" cy="254000"/>
           </a:xfrm>
           <a:prstGeom prst="rect">
@@ -3207,7 +3385,7 @@
         <p:spPr>
           <a:xfrm>
             <a:off x="812800" y="812800"/>
-            <a:ext cx="10883392" cy="238760"/>
+            <a:ext cx="10883392" cy="238720"/>
           </a:xfrm>
           <a:prstGeom prst="rect">
             <a:avLst/>
@@ -3250,8 +3428,8 @@
         </p:nvSpPr>
         <p:spPr>
           <a:xfrm>
-            <a:off x="812800" y="1102364"/>
-            <a:ext cx="10883392" cy="553720"/>
+            <a:off x="812800" y="1102320"/>
+            <a:ext cx="10883392" cy="553690"/>
           </a:xfrm>
           <a:prstGeom prst="rect">
             <a:avLst/>
@@ -3294,12 +3472,12 @@
         </p:nvSpPr>
         <p:spPr>
           <a:xfrm>
-            <a:off x="815975" y="1938654"/>
-            <a:ext cx="3380303" cy="1610360"/>
+            <a:off x="815975" y="1938586"/>
+            <a:ext cx="3380284" cy="1612900"/>
           </a:xfrm>
           <a:prstGeom prst="roundRect">
             <a:avLst>
-              <a:gd name="adj" fmla="val 6112"/>
+              <a:gd name="adj" fmla="val 6102"/>
             </a:avLst>
           </a:prstGeom>
           <a:solidFill>
@@ -3321,8 +3499,8 @@
         </p:nvSpPr>
         <p:spPr>
           <a:xfrm>
-            <a:off x="1021080" y="2143764"/>
-            <a:ext cx="3059196" cy="863600"/>
+            <a:off x="1022350" y="2144961"/>
+            <a:ext cx="3056560" cy="863600"/>
           </a:xfrm>
           <a:prstGeom prst="rect">
             <a:avLst/>
@@ -3365,8 +3543,8 @@
         </p:nvSpPr>
         <p:spPr>
           <a:xfrm>
-            <a:off x="1021080" y="3058164"/>
-            <a:ext cx="3059196" cy="311150"/>
+            <a:off x="1022350" y="3059361"/>
+            <a:ext cx="3056560" cy="311150"/>
           </a:xfrm>
           <a:prstGeom prst="rect">
             <a:avLst/>
@@ -3409,12 +3587,12 @@
         </p:nvSpPr>
         <p:spPr>
           <a:xfrm>
-            <a:off x="4405828" y="1938654"/>
-            <a:ext cx="3380343" cy="1610360"/>
+            <a:off x="4405809" y="1938586"/>
+            <a:ext cx="3380333" cy="1612900"/>
           </a:xfrm>
           <a:prstGeom prst="roundRect">
             <a:avLst>
-              <a:gd name="adj" fmla="val 6112"/>
+              <a:gd name="adj" fmla="val 6102"/>
             </a:avLst>
           </a:prstGeom>
           <a:solidFill>
@@ -3436,8 +3614,8 @@
         </p:nvSpPr>
         <p:spPr>
           <a:xfrm>
-            <a:off x="4610934" y="2143764"/>
-            <a:ext cx="3059237" cy="863600"/>
+            <a:off x="4612184" y="2144961"/>
+            <a:ext cx="3056611" cy="863600"/>
           </a:xfrm>
           <a:prstGeom prst="rect">
             <a:avLst/>
@@ -3480,8 +3658,8 @@
         </p:nvSpPr>
         <p:spPr>
           <a:xfrm>
-            <a:off x="4610934" y="3058164"/>
-            <a:ext cx="3059237" cy="311150"/>
+            <a:off x="4612184" y="3059361"/>
+            <a:ext cx="3056611" cy="311150"/>
           </a:xfrm>
           <a:prstGeom prst="rect">
             <a:avLst/>
@@ -3524,12 +3702,12 @@
         </p:nvSpPr>
         <p:spPr>
           <a:xfrm>
-            <a:off x="7995722" y="1938654"/>
-            <a:ext cx="3380303" cy="1610360"/>
+            <a:off x="7995692" y="1938586"/>
+            <a:ext cx="3380333" cy="1612900"/>
           </a:xfrm>
           <a:prstGeom prst="roundRect">
             <a:avLst>
-              <a:gd name="adj" fmla="val 6112"/>
+              <a:gd name="adj" fmla="val 6102"/>
             </a:avLst>
           </a:prstGeom>
           <a:solidFill>
@@ -3551,8 +3729,8 @@
         </p:nvSpPr>
         <p:spPr>
           <a:xfrm>
-            <a:off x="8200827" y="2143764"/>
-            <a:ext cx="3059196" cy="863600"/>
+            <a:off x="8202067" y="2144961"/>
+            <a:ext cx="3056611" cy="863600"/>
           </a:xfrm>
           <a:prstGeom prst="rect">
             <a:avLst/>
@@ -3595,8 +3773,8 @@
         </p:nvSpPr>
         <p:spPr>
           <a:xfrm>
-            <a:off x="8200827" y="3058164"/>
-            <a:ext cx="3059196" cy="311150"/>
+            <a:off x="8202067" y="3059361"/>
+            <a:ext cx="3056611" cy="311150"/>
           </a:xfrm>
           <a:prstGeom prst="rect">
             <a:avLst/>
@@ -3639,7 +3817,7 @@
         </p:nvSpPr>
         <p:spPr>
           <a:xfrm>
-            <a:off x="812800" y="3856992"/>
+            <a:off x="812800" y="3859461"/>
             <a:ext cx="10566400" cy="590550"/>
           </a:xfrm>
           <a:prstGeom prst="roundRect">
@@ -3661,8 +3839,8 @@
         </p:nvSpPr>
         <p:spPr>
           <a:xfrm>
-            <a:off x="1016000" y="4009392"/>
-            <a:ext cx="1628934" cy="311150"/>
+            <a:off x="1016000" y="4011861"/>
+            <a:ext cx="1628924" cy="311150"/>
           </a:xfrm>
           <a:prstGeom prst="rect">
             <a:avLst/>
@@ -3705,8 +3883,8 @@
         </p:nvSpPr>
         <p:spPr>
           <a:xfrm>
-            <a:off x="2797334" y="4009392"/>
-            <a:ext cx="3885016" cy="311150"/>
+            <a:off x="2797324" y="4011861"/>
+            <a:ext cx="3885057" cy="311150"/>
           </a:xfrm>
           <a:prstGeom prst="rect">
             <a:avLst/>
@@ -3749,7 +3927,7 @@
         </p:nvSpPr>
         <p:spPr>
           <a:xfrm>
-            <a:off x="812800" y="4752342"/>
+            <a:off x="812800" y="4754811"/>
             <a:ext cx="10883392" cy="311150"/>
           </a:xfrm>
           <a:prstGeom prst="rect">
@@ -3796,6 +3974,2130 @@
 <file path=ppt/slides/slide12.xml><?xml version="1.0" encoding="utf-8"?>
 <p:sld xmlns:a="http://schemas.openxmlformats.org/drawingml/2006/main" xmlns:r="http://schemas.openxmlformats.org/officeDocument/2006/relationships" xmlns:p="http://schemas.openxmlformats.org/presentationml/2006/main">
   <p:cSld name="Slide 12">
+    <p:bg>
+      <p:bgPr>
+        <a:solidFill>
+          <a:srgbClr val="F5F3EC"/>
+        </a:solidFill>
+      </p:bgPr>
+    </p:bg>
+    <p:spTree>
+      <p:nvGrpSpPr>
+        <p:cNvPr id="1" name=""/>
+        <p:cNvGrpSpPr/>
+        <p:nvPr/>
+      </p:nvGrpSpPr>
+      <p:grpSpPr>
+        <a:xfrm>
+          <a:off x="0" y="0"/>
+          <a:ext cx="0" cy="0"/>
+          <a:chOff x="0" y="0"/>
+          <a:chExt cx="0" cy="0"/>
+        </a:xfrm>
+      </p:grpSpPr>
+      <p:sp>
+        <p:nvSpPr>
+          <p:cNvPr id="2" name="Text 0"/>
+          <p:cNvSpPr/>
+          <p:nvPr/>
+        </p:nvSpPr>
+        <p:spPr>
+          <a:xfrm>
+            <a:off x="812800" y="812800"/>
+            <a:ext cx="10883392" cy="238720"/>
+          </a:xfrm>
+          <a:prstGeom prst="rect">
+            <a:avLst/>
+          </a:prstGeom>
+          <a:noFill/>
+          <a:ln/>
+        </p:spPr>
+        <p:txBody>
+          <a:bodyPr wrap="square" lIns="0" tIns="0" rIns="0" bIns="0" rtlCol="0" anchor="t">
+            <a:normAutofit/>
+          </a:bodyPr>
+          <a:lstStyle/>
+          <a:p>
+            <a:pPr algn="l" indent="0" marL="0">
+              <a:lnSpc>
+                <a:spcPts val="1680"/>
+              </a:lnSpc>
+              <a:buNone/>
+            </a:pPr>
+            <a:r>
+              <a:rPr lang="en-US" sz="1200" b="1" spc="200" kern="0" dirty="0">
+                <a:solidFill>
+                  <a:srgbClr val="2E7A3C"/>
+                </a:solidFill>
+                <a:latin typeface="Kantumruy Pro" pitchFamily="34" charset="0"/>
+                <a:ea typeface="Kantumruy Pro" pitchFamily="34" charset="-122"/>
+                <a:cs typeface="Kantumruy Pro" pitchFamily="34" charset="-120"/>
+              </a:rPr>
+              <a:t>AI WORKFLOW · CLAUDE CODE</a:t>
+            </a:r>
+            <a:endParaRPr lang="en-US" sz="1200" dirty="0"/>
+          </a:p>
+        </p:txBody>
+      </p:sp>
+      <p:sp>
+        <p:nvSpPr>
+          <p:cNvPr id="3" name="Text 1"/>
+          <p:cNvSpPr/>
+          <p:nvPr/>
+        </p:nvSpPr>
+        <p:spPr>
+          <a:xfrm>
+            <a:off x="812800" y="1102320"/>
+            <a:ext cx="10883392" cy="553690"/>
+          </a:xfrm>
+          <a:prstGeom prst="rect">
+            <a:avLst/>
+          </a:prstGeom>
+          <a:noFill/>
+          <a:ln/>
+        </p:spPr>
+        <p:txBody>
+          <a:bodyPr wrap="square" lIns="0" tIns="0" rIns="0" bIns="0" rtlCol="0" anchor="t">
+            <a:normAutofit/>
+          </a:bodyPr>
+          <a:lstStyle/>
+          <a:p>
+            <a:pPr algn="l" indent="0" marL="0">
+              <a:lnSpc>
+                <a:spcPts val="4160"/>
+              </a:lnSpc>
+              <a:buNone/>
+            </a:pPr>
+            <a:r>
+              <a:rPr lang="en-US" sz="3200" b="1" dirty="0">
+                <a:solidFill>
+                  <a:srgbClr val="13202E"/>
+                </a:solidFill>
+                <a:latin typeface="Kantumruy Pro" pitchFamily="34" charset="0"/>
+                <a:ea typeface="Kantumruy Pro" pitchFamily="34" charset="-122"/>
+                <a:cs typeface="Kantumruy Pro" pitchFamily="34" charset="-120"/>
+              </a:rPr>
+              <a:t>Spec មុន — បន្ទាប់មក កូដ</a:t>
+            </a:r>
+            <a:endParaRPr lang="en-US" sz="3200" dirty="0"/>
+          </a:p>
+        </p:txBody>
+      </p:sp>
+      <p:sp>
+        <p:nvSpPr>
+          <p:cNvPr id="4" name="Shape 2"/>
+          <p:cNvSpPr/>
+          <p:nvPr/>
+        </p:nvSpPr>
+        <p:spPr>
+          <a:xfrm>
+            <a:off x="812800" y="2355106"/>
+            <a:ext cx="10566400" cy="0"/>
+          </a:xfrm>
+          <a:prstGeom prst="line">
+            <a:avLst/>
+          </a:prstGeom>
+          <a:noFill/>
+          <a:ln w="6350">
+            <a:solidFill>
+              <a:srgbClr val="E2DED2"/>
+            </a:solidFill>
+            <a:prstDash val="solid"/>
+          </a:ln>
+        </p:spPr>
+      </p:sp>
+      <p:sp>
+        <p:nvSpPr>
+          <p:cNvPr id="5" name="Text 3"/>
+          <p:cNvSpPr/>
+          <p:nvPr/>
+        </p:nvSpPr>
+        <p:spPr>
+          <a:xfrm>
+            <a:off x="812800" y="2011611"/>
+            <a:ext cx="355600" cy="238720"/>
+          </a:xfrm>
+          <a:prstGeom prst="rect">
+            <a:avLst/>
+          </a:prstGeom>
+          <a:noFill/>
+          <a:ln/>
+        </p:spPr>
+        <p:txBody>
+          <a:bodyPr wrap="square" lIns="0" tIns="0" rIns="0" bIns="0" rtlCol="0" anchor="t">
+            <a:normAutofit/>
+          </a:bodyPr>
+          <a:lstStyle/>
+          <a:p>
+            <a:pPr algn="l" indent="0" marL="0">
+              <a:lnSpc>
+                <a:spcPts val="1680"/>
+              </a:lnSpc>
+              <a:buNone/>
+            </a:pPr>
+            <a:r>
+              <a:rPr lang="en-US" sz="1200" dirty="0">
+                <a:solidFill>
+                  <a:srgbClr val="2E7A3C"/>
+                </a:solidFill>
+                <a:latin typeface="JetBrains Mono" pitchFamily="34" charset="0"/>
+                <a:ea typeface="JetBrains Mono" pitchFamily="34" charset="-122"/>
+                <a:cs typeface="JetBrains Mono" pitchFamily="34" charset="-120"/>
+              </a:rPr>
+              <a:t>1</a:t>
+            </a:r>
+            <a:endParaRPr lang="en-US" sz="1200" dirty="0"/>
+          </a:p>
+        </p:txBody>
+      </p:sp>
+      <p:sp>
+        <p:nvSpPr>
+          <p:cNvPr id="6" name="Text 4"/>
+          <p:cNvSpPr/>
+          <p:nvPr/>
+        </p:nvSpPr>
+        <p:spPr>
+          <a:xfrm>
+            <a:off x="1270000" y="1975396"/>
+            <a:ext cx="9900631" cy="311150"/>
+          </a:xfrm>
+          <a:prstGeom prst="rect">
+            <a:avLst/>
+          </a:prstGeom>
+          <a:noFill/>
+          <a:ln/>
+        </p:spPr>
+        <p:txBody>
+          <a:bodyPr wrap="square" lIns="0" tIns="0" rIns="0" bIns="0" rtlCol="0" anchor="t">
+            <a:normAutofit/>
+          </a:bodyPr>
+          <a:lstStyle/>
+          <a:p>
+            <a:pPr algn="l" indent="0" marL="0">
+              <a:lnSpc>
+                <a:spcPts val="2250"/>
+              </a:lnSpc>
+              <a:buNone/>
+            </a:pPr>
+            <a:r>
+              <a:rPr lang="en-US" sz="1500" dirty="0">
+                <a:solidFill>
+                  <a:srgbClr val="13202E"/>
+                </a:solidFill>
+                <a:latin typeface="Kantumruy Pro" pitchFamily="34" charset="0"/>
+                <a:ea typeface="Kantumruy Pro" pitchFamily="34" charset="-122"/>
+                <a:cs typeface="Kantumruy Pro" pitchFamily="34" charset="-120"/>
+              </a:rPr>
+              <a:t>ផ្តល់ homework និង ច្បាប់ទាំង ៦ ទៅ Claude Code</a:t>
+            </a:r>
+            <a:endParaRPr lang="en-US" sz="1500" dirty="0"/>
+          </a:p>
+        </p:txBody>
+      </p:sp>
+      <p:sp>
+        <p:nvSpPr>
+          <p:cNvPr id="7" name="Shape 5"/>
+          <p:cNvSpPr/>
+          <p:nvPr/>
+        </p:nvSpPr>
+        <p:spPr>
+          <a:xfrm>
+            <a:off x="11034663" y="1960811"/>
+            <a:ext cx="344537" cy="314920"/>
+          </a:xfrm>
+          <a:prstGeom prst="roundRect">
+            <a:avLst>
+              <a:gd name="adj" fmla="val 50000"/>
+            </a:avLst>
+          </a:prstGeom>
+          <a:solidFill>
+            <a:srgbClr val="2E7A3C"/>
+          </a:solidFill>
+          <a:ln/>
+        </p:spPr>
+      </p:sp>
+      <p:sp>
+        <p:nvSpPr>
+          <p:cNvPr id="8" name="Text 6"/>
+          <p:cNvSpPr/>
+          <p:nvPr/>
+        </p:nvSpPr>
+        <p:spPr>
+          <a:xfrm>
+            <a:off x="11161663" y="2011611"/>
+            <a:ext cx="141337" cy="238720"/>
+          </a:xfrm>
+          <a:prstGeom prst="rect">
+            <a:avLst/>
+          </a:prstGeom>
+          <a:noFill/>
+          <a:ln/>
+        </p:spPr>
+        <p:txBody>
+          <a:bodyPr wrap="square" lIns="0" tIns="0" rIns="0" bIns="0" rtlCol="0" anchor="t">
+            <a:normAutofit/>
+          </a:bodyPr>
+          <a:lstStyle/>
+          <a:p>
+            <a:pPr algn="l" indent="0" marL="0">
+              <a:lnSpc>
+                <a:spcPts val="1680"/>
+              </a:lnSpc>
+              <a:buNone/>
+            </a:pPr>
+            <a:r>
+              <a:rPr lang="en-US" sz="1200" dirty="0">
+                <a:solidFill>
+                  <a:srgbClr val="F5F3EC"/>
+                </a:solidFill>
+                <a:latin typeface="Kantumruy Pro" pitchFamily="34" charset="0"/>
+                <a:ea typeface="Kantumruy Pro" pitchFamily="34" charset="-122"/>
+                <a:cs typeface="Kantumruy Pro" pitchFamily="34" charset="-120"/>
+              </a:rPr>
+              <a:t>ខ្ញុំ</a:t>
+            </a:r>
+            <a:endParaRPr lang="en-US" sz="1200" dirty="0"/>
+          </a:p>
+        </p:txBody>
+      </p:sp>
+      <p:sp>
+        <p:nvSpPr>
+          <p:cNvPr id="9" name="Shape 7"/>
+          <p:cNvSpPr/>
+          <p:nvPr/>
+        </p:nvSpPr>
+        <p:spPr>
+          <a:xfrm>
+            <a:off x="812800" y="2828776"/>
+            <a:ext cx="10566400" cy="0"/>
+          </a:xfrm>
+          <a:prstGeom prst="line">
+            <a:avLst/>
+          </a:prstGeom>
+          <a:noFill/>
+          <a:ln w="6350">
+            <a:solidFill>
+              <a:srgbClr val="E2DED2"/>
+            </a:solidFill>
+            <a:prstDash val="solid"/>
+          </a:ln>
+        </p:spPr>
+      </p:sp>
+      <p:sp>
+        <p:nvSpPr>
+          <p:cNvPr id="10" name="Text 8"/>
+          <p:cNvSpPr/>
+          <p:nvPr/>
+        </p:nvSpPr>
+        <p:spPr>
+          <a:xfrm>
+            <a:off x="812800" y="2485281"/>
+            <a:ext cx="355600" cy="238720"/>
+          </a:xfrm>
+          <a:prstGeom prst="rect">
+            <a:avLst/>
+          </a:prstGeom>
+          <a:noFill/>
+          <a:ln/>
+        </p:spPr>
+        <p:txBody>
+          <a:bodyPr wrap="square" lIns="0" tIns="0" rIns="0" bIns="0" rtlCol="0" anchor="t">
+            <a:normAutofit/>
+          </a:bodyPr>
+          <a:lstStyle/>
+          <a:p>
+            <a:pPr algn="l" indent="0" marL="0">
+              <a:lnSpc>
+                <a:spcPts val="1680"/>
+              </a:lnSpc>
+              <a:buNone/>
+            </a:pPr>
+            <a:r>
+              <a:rPr lang="en-US" sz="1200" dirty="0">
+                <a:solidFill>
+                  <a:srgbClr val="2E7A3C"/>
+                </a:solidFill>
+                <a:latin typeface="JetBrains Mono" pitchFamily="34" charset="0"/>
+                <a:ea typeface="JetBrains Mono" pitchFamily="34" charset="-122"/>
+                <a:cs typeface="JetBrains Mono" pitchFamily="34" charset="-120"/>
+              </a:rPr>
+              <a:t>2</a:t>
+            </a:r>
+            <a:endParaRPr lang="en-US" sz="1200" dirty="0"/>
+          </a:p>
+        </p:txBody>
+      </p:sp>
+      <p:sp>
+        <p:nvSpPr>
+          <p:cNvPr id="11" name="Text 9"/>
+          <p:cNvSpPr/>
+          <p:nvPr/>
+        </p:nvSpPr>
+        <p:spPr>
+          <a:xfrm>
+            <a:off x="1270000" y="2449066"/>
+            <a:ext cx="9805487" cy="311150"/>
+          </a:xfrm>
+          <a:prstGeom prst="rect">
+            <a:avLst/>
+          </a:prstGeom>
+          <a:noFill/>
+          <a:ln/>
+        </p:spPr>
+        <p:txBody>
+          <a:bodyPr wrap="square" lIns="0" tIns="0" rIns="0" bIns="0" rtlCol="0" anchor="t">
+            <a:normAutofit/>
+          </a:bodyPr>
+          <a:lstStyle/>
+          <a:p>
+            <a:pPr algn="l" indent="0" marL="0">
+              <a:lnSpc>
+                <a:spcPts val="2250"/>
+              </a:lnSpc>
+              <a:buNone/>
+            </a:pPr>
+            <a:r>
+              <a:rPr lang="en-US" sz="1500" dirty="0">
+                <a:solidFill>
+                  <a:srgbClr val="13202E"/>
+                </a:solidFill>
+                <a:latin typeface="Kantumruy Pro" pitchFamily="34" charset="0"/>
+                <a:ea typeface="Kantumruy Pro" pitchFamily="34" charset="-122"/>
+                <a:cs typeface="Kantumruy Pro" pitchFamily="34" charset="-120"/>
+              </a:rPr>
+              <a:t>សរសេរ DESIGN.md — ច្បាប់, លំដាប់ពិនិត្យ, atomic UPDATE</a:t>
+            </a:r>
+            <a:endParaRPr lang="en-US" sz="1500" dirty="0"/>
+          </a:p>
+        </p:txBody>
+      </p:sp>
+      <p:sp>
+        <p:nvSpPr>
+          <p:cNvPr id="12" name="Shape 10"/>
+          <p:cNvSpPr/>
+          <p:nvPr/>
+        </p:nvSpPr>
+        <p:spPr>
+          <a:xfrm>
+            <a:off x="10942290" y="2434481"/>
+            <a:ext cx="436910" cy="314920"/>
+          </a:xfrm>
+          <a:prstGeom prst="roundRect">
+            <a:avLst>
+              <a:gd name="adj" fmla="val 50000"/>
+            </a:avLst>
+          </a:prstGeom>
+          <a:solidFill>
+            <a:srgbClr val="13202E"/>
+          </a:solidFill>
+          <a:ln/>
+        </p:spPr>
+      </p:sp>
+      <p:sp>
+        <p:nvSpPr>
+          <p:cNvPr id="13" name="Text 11"/>
+          <p:cNvSpPr/>
+          <p:nvPr/>
+        </p:nvSpPr>
+        <p:spPr>
+          <a:xfrm>
+            <a:off x="11069290" y="2485281"/>
+            <a:ext cx="233710" cy="238720"/>
+          </a:xfrm>
+          <a:prstGeom prst="rect">
+            <a:avLst/>
+          </a:prstGeom>
+          <a:noFill/>
+          <a:ln/>
+        </p:spPr>
+        <p:txBody>
+          <a:bodyPr wrap="square" lIns="0" tIns="0" rIns="0" bIns="0" rtlCol="0" anchor="t">
+            <a:normAutofit/>
+          </a:bodyPr>
+          <a:lstStyle/>
+          <a:p>
+            <a:pPr algn="l" indent="0" marL="0">
+              <a:lnSpc>
+                <a:spcPts val="1680"/>
+              </a:lnSpc>
+              <a:buNone/>
+            </a:pPr>
+            <a:r>
+              <a:rPr lang="en-US" sz="1200" dirty="0">
+                <a:solidFill>
+                  <a:srgbClr val="F5F3EC"/>
+                </a:solidFill>
+                <a:latin typeface="JetBrains Mono" pitchFamily="34" charset="0"/>
+                <a:ea typeface="JetBrains Mono" pitchFamily="34" charset="-122"/>
+                <a:cs typeface="JetBrains Mono" pitchFamily="34" charset="-120"/>
+              </a:rPr>
+              <a:t>AI</a:t>
+            </a:r>
+            <a:endParaRPr lang="en-US" sz="1200" dirty="0"/>
+          </a:p>
+        </p:txBody>
+      </p:sp>
+      <p:sp>
+        <p:nvSpPr>
+          <p:cNvPr id="14" name="Shape 12"/>
+          <p:cNvSpPr/>
+          <p:nvPr/>
+        </p:nvSpPr>
+        <p:spPr>
+          <a:xfrm>
+            <a:off x="812800" y="3302446"/>
+            <a:ext cx="10566400" cy="0"/>
+          </a:xfrm>
+          <a:prstGeom prst="line">
+            <a:avLst/>
+          </a:prstGeom>
+          <a:noFill/>
+          <a:ln w="6350">
+            <a:solidFill>
+              <a:srgbClr val="E2DED2"/>
+            </a:solidFill>
+            <a:prstDash val="solid"/>
+          </a:ln>
+        </p:spPr>
+      </p:sp>
+      <p:sp>
+        <p:nvSpPr>
+          <p:cNvPr id="15" name="Text 13"/>
+          <p:cNvSpPr/>
+          <p:nvPr/>
+        </p:nvSpPr>
+        <p:spPr>
+          <a:xfrm>
+            <a:off x="812800" y="2958951"/>
+            <a:ext cx="355600" cy="238720"/>
+          </a:xfrm>
+          <a:prstGeom prst="rect">
+            <a:avLst/>
+          </a:prstGeom>
+          <a:noFill/>
+          <a:ln/>
+        </p:spPr>
+        <p:txBody>
+          <a:bodyPr wrap="square" lIns="0" tIns="0" rIns="0" bIns="0" rtlCol="0" anchor="t">
+            <a:normAutofit/>
+          </a:bodyPr>
+          <a:lstStyle/>
+          <a:p>
+            <a:pPr algn="l" indent="0" marL="0">
+              <a:lnSpc>
+                <a:spcPts val="1680"/>
+              </a:lnSpc>
+              <a:buNone/>
+            </a:pPr>
+            <a:r>
+              <a:rPr lang="en-US" sz="1200" dirty="0">
+                <a:solidFill>
+                  <a:srgbClr val="2E7A3C"/>
+                </a:solidFill>
+                <a:latin typeface="JetBrains Mono" pitchFamily="34" charset="0"/>
+                <a:ea typeface="JetBrains Mono" pitchFamily="34" charset="-122"/>
+                <a:cs typeface="JetBrains Mono" pitchFamily="34" charset="-120"/>
+              </a:rPr>
+              <a:t>3</a:t>
+            </a:r>
+            <a:endParaRPr lang="en-US" sz="1200" dirty="0"/>
+          </a:p>
+        </p:txBody>
+      </p:sp>
+      <p:sp>
+        <p:nvSpPr>
+          <p:cNvPr id="16" name="Text 14"/>
+          <p:cNvSpPr/>
+          <p:nvPr/>
+        </p:nvSpPr>
+        <p:spPr>
+          <a:xfrm>
+            <a:off x="1270000" y="2922736"/>
+            <a:ext cx="9900631" cy="311150"/>
+          </a:xfrm>
+          <a:prstGeom prst="rect">
+            <a:avLst/>
+          </a:prstGeom>
+          <a:noFill/>
+          <a:ln/>
+        </p:spPr>
+        <p:txBody>
+          <a:bodyPr wrap="square" lIns="0" tIns="0" rIns="0" bIns="0" rtlCol="0" anchor="t">
+            <a:normAutofit/>
+          </a:bodyPr>
+          <a:lstStyle/>
+          <a:p>
+            <a:pPr algn="l" indent="0" marL="0">
+              <a:lnSpc>
+                <a:spcPts val="2250"/>
+              </a:lnSpc>
+              <a:buNone/>
+            </a:pPr>
+            <a:r>
+              <a:rPr lang="en-US" sz="1500" dirty="0">
+                <a:solidFill>
+                  <a:srgbClr val="13202E"/>
+                </a:solidFill>
+                <a:latin typeface="Kantumruy Pro" pitchFamily="34" charset="0"/>
+                <a:ea typeface="Kantumruy Pro" pitchFamily="34" charset="-122"/>
+                <a:cs typeface="Kantumruy Pro" pitchFamily="34" charset="-120"/>
+              </a:rPr>
+              <a:t>Review design មុនសរសេរកូដ</a:t>
+            </a:r>
+            <a:endParaRPr lang="en-US" sz="1500" dirty="0"/>
+          </a:p>
+        </p:txBody>
+      </p:sp>
+      <p:sp>
+        <p:nvSpPr>
+          <p:cNvPr id="17" name="Shape 15"/>
+          <p:cNvSpPr/>
+          <p:nvPr/>
+        </p:nvSpPr>
+        <p:spPr>
+          <a:xfrm>
+            <a:off x="11034663" y="2908151"/>
+            <a:ext cx="344537" cy="314920"/>
+          </a:xfrm>
+          <a:prstGeom prst="roundRect">
+            <a:avLst>
+              <a:gd name="adj" fmla="val 50000"/>
+            </a:avLst>
+          </a:prstGeom>
+          <a:solidFill>
+            <a:srgbClr val="2E7A3C"/>
+          </a:solidFill>
+          <a:ln/>
+        </p:spPr>
+      </p:sp>
+      <p:sp>
+        <p:nvSpPr>
+          <p:cNvPr id="18" name="Text 16"/>
+          <p:cNvSpPr/>
+          <p:nvPr/>
+        </p:nvSpPr>
+        <p:spPr>
+          <a:xfrm>
+            <a:off x="11161663" y="2958951"/>
+            <a:ext cx="141337" cy="238720"/>
+          </a:xfrm>
+          <a:prstGeom prst="rect">
+            <a:avLst/>
+          </a:prstGeom>
+          <a:noFill/>
+          <a:ln/>
+        </p:spPr>
+        <p:txBody>
+          <a:bodyPr wrap="square" lIns="0" tIns="0" rIns="0" bIns="0" rtlCol="0" anchor="t">
+            <a:normAutofit/>
+          </a:bodyPr>
+          <a:lstStyle/>
+          <a:p>
+            <a:pPr algn="l" indent="0" marL="0">
+              <a:lnSpc>
+                <a:spcPts val="1680"/>
+              </a:lnSpc>
+              <a:buNone/>
+            </a:pPr>
+            <a:r>
+              <a:rPr lang="en-US" sz="1200" dirty="0">
+                <a:solidFill>
+                  <a:srgbClr val="F5F3EC"/>
+                </a:solidFill>
+                <a:latin typeface="Kantumruy Pro" pitchFamily="34" charset="0"/>
+                <a:ea typeface="Kantumruy Pro" pitchFamily="34" charset="-122"/>
+                <a:cs typeface="Kantumruy Pro" pitchFamily="34" charset="-120"/>
+              </a:rPr>
+              <a:t>ខ្ញុំ</a:t>
+            </a:r>
+            <a:endParaRPr lang="en-US" sz="1200" dirty="0"/>
+          </a:p>
+        </p:txBody>
+      </p:sp>
+      <p:sp>
+        <p:nvSpPr>
+          <p:cNvPr id="19" name="Shape 17"/>
+          <p:cNvSpPr/>
+          <p:nvPr/>
+        </p:nvSpPr>
+        <p:spPr>
+          <a:xfrm>
+            <a:off x="812800" y="3776117"/>
+            <a:ext cx="10566400" cy="0"/>
+          </a:xfrm>
+          <a:prstGeom prst="line">
+            <a:avLst/>
+          </a:prstGeom>
+          <a:noFill/>
+          <a:ln w="6350">
+            <a:solidFill>
+              <a:srgbClr val="E2DED2"/>
+            </a:solidFill>
+            <a:prstDash val="solid"/>
+          </a:ln>
+        </p:spPr>
+      </p:sp>
+      <p:sp>
+        <p:nvSpPr>
+          <p:cNvPr id="20" name="Text 18"/>
+          <p:cNvSpPr/>
+          <p:nvPr/>
+        </p:nvSpPr>
+        <p:spPr>
+          <a:xfrm>
+            <a:off x="812800" y="3432621"/>
+            <a:ext cx="355600" cy="238720"/>
+          </a:xfrm>
+          <a:prstGeom prst="rect">
+            <a:avLst/>
+          </a:prstGeom>
+          <a:noFill/>
+          <a:ln/>
+        </p:spPr>
+        <p:txBody>
+          <a:bodyPr wrap="square" lIns="0" tIns="0" rIns="0" bIns="0" rtlCol="0" anchor="t">
+            <a:normAutofit/>
+          </a:bodyPr>
+          <a:lstStyle/>
+          <a:p>
+            <a:pPr algn="l" indent="0" marL="0">
+              <a:lnSpc>
+                <a:spcPts val="1680"/>
+              </a:lnSpc>
+              <a:buNone/>
+            </a:pPr>
+            <a:r>
+              <a:rPr lang="en-US" sz="1200" dirty="0">
+                <a:solidFill>
+                  <a:srgbClr val="2E7A3C"/>
+                </a:solidFill>
+                <a:latin typeface="JetBrains Mono" pitchFamily="34" charset="0"/>
+                <a:ea typeface="JetBrains Mono" pitchFamily="34" charset="-122"/>
+                <a:cs typeface="JetBrains Mono" pitchFamily="34" charset="-120"/>
+              </a:rPr>
+              <a:t>4</a:t>
+            </a:r>
+            <a:endParaRPr lang="en-US" sz="1200" dirty="0"/>
+          </a:p>
+        </p:txBody>
+      </p:sp>
+      <p:sp>
+        <p:nvSpPr>
+          <p:cNvPr id="21" name="Text 19"/>
+          <p:cNvSpPr/>
+          <p:nvPr/>
+        </p:nvSpPr>
+        <p:spPr>
+          <a:xfrm>
+            <a:off x="1270000" y="3396407"/>
+            <a:ext cx="9805487" cy="311150"/>
+          </a:xfrm>
+          <a:prstGeom prst="rect">
+            <a:avLst/>
+          </a:prstGeom>
+          <a:noFill/>
+          <a:ln/>
+        </p:spPr>
+        <p:txBody>
+          <a:bodyPr wrap="square" lIns="0" tIns="0" rIns="0" bIns="0" rtlCol="0" anchor="t">
+            <a:normAutofit/>
+          </a:bodyPr>
+          <a:lstStyle/>
+          <a:p>
+            <a:pPr algn="l" indent="0" marL="0">
+              <a:lnSpc>
+                <a:spcPts val="2250"/>
+              </a:lnSpc>
+              <a:buNone/>
+            </a:pPr>
+            <a:r>
+              <a:rPr lang="en-US" sz="1500" dirty="0">
+                <a:solidFill>
+                  <a:srgbClr val="13202E"/>
+                </a:solidFill>
+                <a:latin typeface="Kantumruy Pro" pitchFamily="34" charset="0"/>
+                <a:ea typeface="Kantumruy Pro" pitchFamily="34" charset="-122"/>
+                <a:cs typeface="Kantumruy Pro" pitchFamily="34" charset="-120"/>
+              </a:rPr>
+              <a:t>សរសេរកូដ តាម design — Controller, Service, Repository</a:t>
+            </a:r>
+            <a:endParaRPr lang="en-US" sz="1500" dirty="0"/>
+          </a:p>
+        </p:txBody>
+      </p:sp>
+      <p:sp>
+        <p:nvSpPr>
+          <p:cNvPr id="22" name="Shape 20"/>
+          <p:cNvSpPr/>
+          <p:nvPr/>
+        </p:nvSpPr>
+        <p:spPr>
+          <a:xfrm>
+            <a:off x="10942290" y="3381821"/>
+            <a:ext cx="436910" cy="314920"/>
+          </a:xfrm>
+          <a:prstGeom prst="roundRect">
+            <a:avLst>
+              <a:gd name="adj" fmla="val 50000"/>
+            </a:avLst>
+          </a:prstGeom>
+          <a:solidFill>
+            <a:srgbClr val="13202E"/>
+          </a:solidFill>
+          <a:ln/>
+        </p:spPr>
+      </p:sp>
+      <p:sp>
+        <p:nvSpPr>
+          <p:cNvPr id="23" name="Text 21"/>
+          <p:cNvSpPr/>
+          <p:nvPr/>
+        </p:nvSpPr>
+        <p:spPr>
+          <a:xfrm>
+            <a:off x="11069290" y="3432621"/>
+            <a:ext cx="233710" cy="238720"/>
+          </a:xfrm>
+          <a:prstGeom prst="rect">
+            <a:avLst/>
+          </a:prstGeom>
+          <a:noFill/>
+          <a:ln/>
+        </p:spPr>
+        <p:txBody>
+          <a:bodyPr wrap="square" lIns="0" tIns="0" rIns="0" bIns="0" rtlCol="0" anchor="t">
+            <a:normAutofit/>
+          </a:bodyPr>
+          <a:lstStyle/>
+          <a:p>
+            <a:pPr algn="l" indent="0" marL="0">
+              <a:lnSpc>
+                <a:spcPts val="1680"/>
+              </a:lnSpc>
+              <a:buNone/>
+            </a:pPr>
+            <a:r>
+              <a:rPr lang="en-US" sz="1200" dirty="0">
+                <a:solidFill>
+                  <a:srgbClr val="F5F3EC"/>
+                </a:solidFill>
+                <a:latin typeface="JetBrains Mono" pitchFamily="34" charset="0"/>
+                <a:ea typeface="JetBrains Mono" pitchFamily="34" charset="-122"/>
+                <a:cs typeface="JetBrains Mono" pitchFamily="34" charset="-120"/>
+              </a:rPr>
+              <a:t>AI</a:t>
+            </a:r>
+            <a:endParaRPr lang="en-US" sz="1200" dirty="0"/>
+          </a:p>
+        </p:txBody>
+      </p:sp>
+      <p:sp>
+        <p:nvSpPr>
+          <p:cNvPr id="24" name="Shape 22"/>
+          <p:cNvSpPr/>
+          <p:nvPr/>
+        </p:nvSpPr>
+        <p:spPr>
+          <a:xfrm>
+            <a:off x="812800" y="4249787"/>
+            <a:ext cx="10566400" cy="0"/>
+          </a:xfrm>
+          <a:prstGeom prst="line">
+            <a:avLst/>
+          </a:prstGeom>
+          <a:noFill/>
+          <a:ln w="6350">
+            <a:solidFill>
+              <a:srgbClr val="E2DED2"/>
+            </a:solidFill>
+            <a:prstDash val="solid"/>
+          </a:ln>
+        </p:spPr>
+      </p:sp>
+      <p:sp>
+        <p:nvSpPr>
+          <p:cNvPr id="25" name="Text 23"/>
+          <p:cNvSpPr/>
+          <p:nvPr/>
+        </p:nvSpPr>
+        <p:spPr>
+          <a:xfrm>
+            <a:off x="812800" y="3906292"/>
+            <a:ext cx="355600" cy="238720"/>
+          </a:xfrm>
+          <a:prstGeom prst="rect">
+            <a:avLst/>
+          </a:prstGeom>
+          <a:noFill/>
+          <a:ln/>
+        </p:spPr>
+        <p:txBody>
+          <a:bodyPr wrap="square" lIns="0" tIns="0" rIns="0" bIns="0" rtlCol="0" anchor="t">
+            <a:normAutofit/>
+          </a:bodyPr>
+          <a:lstStyle/>
+          <a:p>
+            <a:pPr algn="l" indent="0" marL="0">
+              <a:lnSpc>
+                <a:spcPts val="1680"/>
+              </a:lnSpc>
+              <a:buNone/>
+            </a:pPr>
+            <a:r>
+              <a:rPr lang="en-US" sz="1200" dirty="0">
+                <a:solidFill>
+                  <a:srgbClr val="2E7A3C"/>
+                </a:solidFill>
+                <a:latin typeface="JetBrains Mono" pitchFamily="34" charset="0"/>
+                <a:ea typeface="JetBrains Mono" pitchFamily="34" charset="-122"/>
+                <a:cs typeface="JetBrains Mono" pitchFamily="34" charset="-120"/>
+              </a:rPr>
+              <a:t>5</a:t>
+            </a:r>
+            <a:endParaRPr lang="en-US" sz="1200" dirty="0"/>
+          </a:p>
+        </p:txBody>
+      </p:sp>
+      <p:sp>
+        <p:nvSpPr>
+          <p:cNvPr id="26" name="Text 24"/>
+          <p:cNvSpPr/>
+          <p:nvPr/>
+        </p:nvSpPr>
+        <p:spPr>
+          <a:xfrm>
+            <a:off x="1270000" y="3870077"/>
+            <a:ext cx="9805487" cy="311150"/>
+          </a:xfrm>
+          <a:prstGeom prst="rect">
+            <a:avLst/>
+          </a:prstGeom>
+          <a:noFill/>
+          <a:ln/>
+        </p:spPr>
+        <p:txBody>
+          <a:bodyPr wrap="square" lIns="0" tIns="0" rIns="0" bIns="0" rtlCol="0" anchor="t">
+            <a:normAutofit/>
+          </a:bodyPr>
+          <a:lstStyle/>
+          <a:p>
+            <a:pPr algn="l" indent="0" marL="0">
+              <a:lnSpc>
+                <a:spcPts val="2250"/>
+              </a:lnSpc>
+              <a:buNone/>
+            </a:pPr>
+            <a:r>
+              <a:rPr lang="en-US" sz="1500" dirty="0">
+                <a:solidFill>
+                  <a:srgbClr val="13202E"/>
+                </a:solidFill>
+                <a:latin typeface="Kantumruy Pro" pitchFamily="34" charset="0"/>
+                <a:ea typeface="Kantumruy Pro" pitchFamily="34" charset="-122"/>
+                <a:cs typeface="Kantumruy Pro" pitchFamily="34" charset="-120"/>
+              </a:rPr>
+              <a:t>សរសេរ tests — MockMvc និង concurrency test</a:t>
+            </a:r>
+            <a:endParaRPr lang="en-US" sz="1500" dirty="0"/>
+          </a:p>
+        </p:txBody>
+      </p:sp>
+      <p:sp>
+        <p:nvSpPr>
+          <p:cNvPr id="27" name="Shape 25"/>
+          <p:cNvSpPr/>
+          <p:nvPr/>
+        </p:nvSpPr>
+        <p:spPr>
+          <a:xfrm>
+            <a:off x="10942290" y="3855492"/>
+            <a:ext cx="436910" cy="314920"/>
+          </a:xfrm>
+          <a:prstGeom prst="roundRect">
+            <a:avLst>
+              <a:gd name="adj" fmla="val 50000"/>
+            </a:avLst>
+          </a:prstGeom>
+          <a:solidFill>
+            <a:srgbClr val="13202E"/>
+          </a:solidFill>
+          <a:ln/>
+        </p:spPr>
+      </p:sp>
+      <p:sp>
+        <p:nvSpPr>
+          <p:cNvPr id="28" name="Text 26"/>
+          <p:cNvSpPr/>
+          <p:nvPr/>
+        </p:nvSpPr>
+        <p:spPr>
+          <a:xfrm>
+            <a:off x="11069290" y="3906292"/>
+            <a:ext cx="233710" cy="238720"/>
+          </a:xfrm>
+          <a:prstGeom prst="rect">
+            <a:avLst/>
+          </a:prstGeom>
+          <a:noFill/>
+          <a:ln/>
+        </p:spPr>
+        <p:txBody>
+          <a:bodyPr wrap="square" lIns="0" tIns="0" rIns="0" bIns="0" rtlCol="0" anchor="t">
+            <a:normAutofit/>
+          </a:bodyPr>
+          <a:lstStyle/>
+          <a:p>
+            <a:pPr algn="l" indent="0" marL="0">
+              <a:lnSpc>
+                <a:spcPts val="1680"/>
+              </a:lnSpc>
+              <a:buNone/>
+            </a:pPr>
+            <a:r>
+              <a:rPr lang="en-US" sz="1200" dirty="0">
+                <a:solidFill>
+                  <a:srgbClr val="F5F3EC"/>
+                </a:solidFill>
+                <a:latin typeface="JetBrains Mono" pitchFamily="34" charset="0"/>
+                <a:ea typeface="JetBrains Mono" pitchFamily="34" charset="-122"/>
+                <a:cs typeface="JetBrains Mono" pitchFamily="34" charset="-120"/>
+              </a:rPr>
+              <a:t>AI</a:t>
+            </a:r>
+            <a:endParaRPr lang="en-US" sz="1200" dirty="0"/>
+          </a:p>
+        </p:txBody>
+      </p:sp>
+      <p:sp>
+        <p:nvSpPr>
+          <p:cNvPr id="29" name="Text 27"/>
+          <p:cNvSpPr/>
+          <p:nvPr/>
+        </p:nvSpPr>
+        <p:spPr>
+          <a:xfrm>
+            <a:off x="812800" y="4379962"/>
+            <a:ext cx="355600" cy="238720"/>
+          </a:xfrm>
+          <a:prstGeom prst="rect">
+            <a:avLst/>
+          </a:prstGeom>
+          <a:noFill/>
+          <a:ln/>
+        </p:spPr>
+        <p:txBody>
+          <a:bodyPr wrap="square" lIns="0" tIns="0" rIns="0" bIns="0" rtlCol="0" anchor="t">
+            <a:normAutofit/>
+          </a:bodyPr>
+          <a:lstStyle/>
+          <a:p>
+            <a:pPr algn="l" indent="0" marL="0">
+              <a:lnSpc>
+                <a:spcPts val="1680"/>
+              </a:lnSpc>
+              <a:buNone/>
+            </a:pPr>
+            <a:r>
+              <a:rPr lang="en-US" sz="1200" dirty="0">
+                <a:solidFill>
+                  <a:srgbClr val="2E7A3C"/>
+                </a:solidFill>
+                <a:latin typeface="JetBrains Mono" pitchFamily="34" charset="0"/>
+                <a:ea typeface="JetBrains Mono" pitchFamily="34" charset="-122"/>
+                <a:cs typeface="JetBrains Mono" pitchFamily="34" charset="-120"/>
+              </a:rPr>
+              <a:t>6</a:t>
+            </a:r>
+            <a:endParaRPr lang="en-US" sz="1200" dirty="0"/>
+          </a:p>
+        </p:txBody>
+      </p:sp>
+      <p:sp>
+        <p:nvSpPr>
+          <p:cNvPr id="30" name="Text 28"/>
+          <p:cNvSpPr/>
+          <p:nvPr/>
+        </p:nvSpPr>
+        <p:spPr>
+          <a:xfrm>
+            <a:off x="1270000" y="4343747"/>
+            <a:ext cx="9900631" cy="311150"/>
+          </a:xfrm>
+          <a:prstGeom prst="rect">
+            <a:avLst/>
+          </a:prstGeom>
+          <a:noFill/>
+          <a:ln/>
+        </p:spPr>
+        <p:txBody>
+          <a:bodyPr wrap="square" lIns="0" tIns="0" rIns="0" bIns="0" rtlCol="0" anchor="t">
+            <a:normAutofit/>
+          </a:bodyPr>
+          <a:lstStyle/>
+          <a:p>
+            <a:pPr algn="l" indent="0" marL="0">
+              <a:lnSpc>
+                <a:spcPts val="2250"/>
+              </a:lnSpc>
+              <a:buNone/>
+            </a:pPr>
+            <a:r>
+              <a:rPr lang="en-US" sz="1500" dirty="0">
+                <a:solidFill>
+                  <a:srgbClr val="13202E"/>
+                </a:solidFill>
+                <a:latin typeface="Kantumruy Pro" pitchFamily="34" charset="0"/>
+                <a:ea typeface="Kantumruy Pro" pitchFamily="34" charset="-122"/>
+                <a:cs typeface="Kantumruy Pro" pitchFamily="34" charset="-120"/>
+              </a:rPr>
+              <a:t>រត់ ./gradlew test និង review diff មុន commit</a:t>
+            </a:r>
+            <a:endParaRPr lang="en-US" sz="1500" dirty="0"/>
+          </a:p>
+        </p:txBody>
+      </p:sp>
+      <p:sp>
+        <p:nvSpPr>
+          <p:cNvPr id="31" name="Shape 29"/>
+          <p:cNvSpPr/>
+          <p:nvPr/>
+        </p:nvSpPr>
+        <p:spPr>
+          <a:xfrm>
+            <a:off x="11034663" y="4329162"/>
+            <a:ext cx="344537" cy="314920"/>
+          </a:xfrm>
+          <a:prstGeom prst="roundRect">
+            <a:avLst>
+              <a:gd name="adj" fmla="val 50000"/>
+            </a:avLst>
+          </a:prstGeom>
+          <a:solidFill>
+            <a:srgbClr val="2E7A3C"/>
+          </a:solidFill>
+          <a:ln/>
+        </p:spPr>
+      </p:sp>
+      <p:sp>
+        <p:nvSpPr>
+          <p:cNvPr id="32" name="Text 30"/>
+          <p:cNvSpPr/>
+          <p:nvPr/>
+        </p:nvSpPr>
+        <p:spPr>
+          <a:xfrm>
+            <a:off x="11161663" y="4379962"/>
+            <a:ext cx="141337" cy="238720"/>
+          </a:xfrm>
+          <a:prstGeom prst="rect">
+            <a:avLst/>
+          </a:prstGeom>
+          <a:noFill/>
+          <a:ln/>
+        </p:spPr>
+        <p:txBody>
+          <a:bodyPr wrap="square" lIns="0" tIns="0" rIns="0" bIns="0" rtlCol="0" anchor="t">
+            <a:normAutofit/>
+          </a:bodyPr>
+          <a:lstStyle/>
+          <a:p>
+            <a:pPr algn="l" indent="0" marL="0">
+              <a:lnSpc>
+                <a:spcPts val="1680"/>
+              </a:lnSpc>
+              <a:buNone/>
+            </a:pPr>
+            <a:r>
+              <a:rPr lang="en-US" sz="1200" dirty="0">
+                <a:solidFill>
+                  <a:srgbClr val="F5F3EC"/>
+                </a:solidFill>
+                <a:latin typeface="Kantumruy Pro" pitchFamily="34" charset="0"/>
+                <a:ea typeface="Kantumruy Pro" pitchFamily="34" charset="-122"/>
+                <a:cs typeface="Kantumruy Pro" pitchFamily="34" charset="-120"/>
+              </a:rPr>
+              <a:t>ខ្ញុំ</a:t>
+            </a:r>
+            <a:endParaRPr lang="en-US" sz="1200" dirty="0"/>
+          </a:p>
+        </p:txBody>
+      </p:sp>
+      <p:sp>
+        <p:nvSpPr>
+          <p:cNvPr id="33" name="Text 31"/>
+          <p:cNvSpPr/>
+          <p:nvPr/>
+        </p:nvSpPr>
+        <p:spPr>
+          <a:xfrm>
+            <a:off x="812800" y="4974282"/>
+            <a:ext cx="10883392" cy="311150"/>
+          </a:xfrm>
+          <a:prstGeom prst="rect">
+            <a:avLst/>
+          </a:prstGeom>
+          <a:noFill/>
+          <a:ln/>
+        </p:spPr>
+        <p:txBody>
+          <a:bodyPr wrap="square" lIns="0" tIns="0" rIns="0" bIns="0" rtlCol="0" anchor="t">
+            <a:normAutofit/>
+          </a:bodyPr>
+          <a:lstStyle/>
+          <a:p>
+            <a:pPr algn="l" indent="0" marL="0">
+              <a:lnSpc>
+                <a:spcPts val="2250"/>
+              </a:lnSpc>
+              <a:buNone/>
+            </a:pPr>
+            <a:r>
+              <a:rPr lang="en-US" sz="1500" b="1" dirty="0">
+                <a:solidFill>
+                  <a:srgbClr val="4A5361"/>
+                </a:solidFill>
+                <a:latin typeface="Kantumruy Pro" pitchFamily="34" charset="0"/>
+                <a:ea typeface="Kantumruy Pro" pitchFamily="34" charset="-122"/>
+                <a:cs typeface="Kantumruy Pro" pitchFamily="34" charset="-120"/>
+              </a:rPr>
+              <a:t>ហេតុអ្វី spec មុន?</a:t>
+            </a:r>
+            <a:r>
+              <a:rPr lang="en-US" sz="1500" dirty="0">
+                <a:solidFill>
+                  <a:srgbClr val="4A5361"/>
+                </a:solidFill>
+                <a:latin typeface="Kantumruy Pro" pitchFamily="34" charset="0"/>
+                <a:ea typeface="Kantumruy Pro" pitchFamily="34" charset="-122"/>
+                <a:cs typeface="Kantumruy Pro" pitchFamily="34" charset="-120"/>
+              </a:rPr>
+              <a:t> AI សរសេរកូដ តាមឯកសារ ដែលខ្ញុំបាន review រួច — មិនមែនទាយ។</a:t>
+            </a:r>
+            <a:endParaRPr lang="en-US" sz="1500" dirty="0"/>
+          </a:p>
+        </p:txBody>
+      </p:sp>
+    </p:spTree>
+  </p:cSld>
+  <p:clrMapOvr>
+    <a:masterClrMapping/>
+  </p:clrMapOvr>
+</p:sld>
+</file>
+
+<file path=ppt/slides/slide13.xml><?xml version="1.0" encoding="utf-8"?>
+<p:sld xmlns:a="http://schemas.openxmlformats.org/drawingml/2006/main" xmlns:r="http://schemas.openxmlformats.org/officeDocument/2006/relationships" xmlns:p="http://schemas.openxmlformats.org/presentationml/2006/main">
+  <p:cSld name="Slide 13">
+    <p:bg>
+      <p:bgPr>
+        <a:solidFill>
+          <a:srgbClr val="F5F3EC"/>
+        </a:solidFill>
+      </p:bgPr>
+    </p:bg>
+    <p:spTree>
+      <p:nvGrpSpPr>
+        <p:cNvPr id="1" name=""/>
+        <p:cNvGrpSpPr/>
+        <p:nvPr/>
+      </p:nvGrpSpPr>
+      <p:grpSpPr>
+        <a:xfrm>
+          <a:off x="0" y="0"/>
+          <a:ext cx="0" cy="0"/>
+          <a:chOff x="0" y="0"/>
+          <a:chExt cx="0" cy="0"/>
+        </a:xfrm>
+      </p:grpSpPr>
+      <p:sp>
+        <p:nvSpPr>
+          <p:cNvPr id="2" name="Text 0"/>
+          <p:cNvSpPr/>
+          <p:nvPr/>
+        </p:nvSpPr>
+        <p:spPr>
+          <a:xfrm>
+            <a:off x="812800" y="812800"/>
+            <a:ext cx="10883392" cy="238720"/>
+          </a:xfrm>
+          <a:prstGeom prst="rect">
+            <a:avLst/>
+          </a:prstGeom>
+          <a:noFill/>
+          <a:ln/>
+        </p:spPr>
+        <p:txBody>
+          <a:bodyPr wrap="square" lIns="0" tIns="0" rIns="0" bIns="0" rtlCol="0" anchor="t">
+            <a:normAutofit/>
+          </a:bodyPr>
+          <a:lstStyle/>
+          <a:p>
+            <a:pPr algn="l" indent="0" marL="0">
+              <a:lnSpc>
+                <a:spcPts val="1680"/>
+              </a:lnSpc>
+              <a:buNone/>
+            </a:pPr>
+            <a:r>
+              <a:rPr lang="en-US" sz="1200" b="1" spc="200" kern="0" dirty="0">
+                <a:solidFill>
+                  <a:srgbClr val="2E7A3C"/>
+                </a:solidFill>
+                <a:latin typeface="Kantumruy Pro" pitchFamily="34" charset="0"/>
+                <a:ea typeface="Kantumruy Pro" pitchFamily="34" charset="-122"/>
+                <a:cs typeface="Kantumruy Pro" pitchFamily="34" charset="-120"/>
+              </a:rPr>
+              <a:t>AI WORKFLOW · ការអនុវត្ត</a:t>
+            </a:r>
+            <a:endParaRPr lang="en-US" sz="1200" dirty="0"/>
+          </a:p>
+        </p:txBody>
+      </p:sp>
+      <p:sp>
+        <p:nvSpPr>
+          <p:cNvPr id="3" name="Text 1"/>
+          <p:cNvSpPr/>
+          <p:nvPr/>
+        </p:nvSpPr>
+        <p:spPr>
+          <a:xfrm>
+            <a:off x="812800" y="1102320"/>
+            <a:ext cx="10883392" cy="553690"/>
+          </a:xfrm>
+          <a:prstGeom prst="rect">
+            <a:avLst/>
+          </a:prstGeom>
+          <a:noFill/>
+          <a:ln/>
+        </p:spPr>
+        <p:txBody>
+          <a:bodyPr wrap="square" lIns="0" tIns="0" rIns="0" bIns="0" rtlCol="0" anchor="t">
+            <a:normAutofit/>
+          </a:bodyPr>
+          <a:lstStyle/>
+          <a:p>
+            <a:pPr algn="l" indent="0" marL="0">
+              <a:lnSpc>
+                <a:spcPts val="4160"/>
+              </a:lnSpc>
+              <a:buNone/>
+            </a:pPr>
+            <a:r>
+              <a:rPr lang="en-US" sz="3200" b="1" dirty="0">
+                <a:solidFill>
+                  <a:srgbClr val="13202E"/>
+                </a:solidFill>
+                <a:latin typeface="Kantumruy Pro" pitchFamily="34" charset="0"/>
+                <a:ea typeface="Kantumruy Pro" pitchFamily="34" charset="-122"/>
+                <a:cs typeface="Kantumruy Pro" pitchFamily="34" charset="-120"/>
+              </a:rPr>
+              <a:t>AI សរសេរ — ខ្ញុំ ផ្ទៀងផ្ទាត់</a:t>
+            </a:r>
+            <a:endParaRPr lang="en-US" sz="3200" dirty="0"/>
+          </a:p>
+        </p:txBody>
+      </p:sp>
+      <p:sp>
+        <p:nvSpPr>
+          <p:cNvPr id="4" name="Text 2"/>
+          <p:cNvSpPr/>
+          <p:nvPr/>
+        </p:nvSpPr>
+        <p:spPr>
+          <a:xfrm>
+            <a:off x="812800" y="1935411"/>
+            <a:ext cx="5284724" cy="355600"/>
+          </a:xfrm>
+          <a:prstGeom prst="rect">
+            <a:avLst/>
+          </a:prstGeom>
+          <a:noFill/>
+          <a:ln/>
+        </p:spPr>
+        <p:txBody>
+          <a:bodyPr wrap="square" lIns="0" tIns="0" rIns="0" bIns="0" rtlCol="0" anchor="t">
+            <a:normAutofit/>
+          </a:bodyPr>
+          <a:lstStyle/>
+          <a:p>
+            <a:pPr algn="l" indent="0" marL="0">
+              <a:lnSpc>
+                <a:spcPts val="2600"/>
+              </a:lnSpc>
+              <a:buNone/>
+            </a:pPr>
+            <a:r>
+              <a:rPr lang="en-US" sz="2000" b="1" dirty="0">
+                <a:solidFill>
+                  <a:srgbClr val="13202E"/>
+                </a:solidFill>
+                <a:latin typeface="Kantumruy Pro" pitchFamily="34" charset="0"/>
+                <a:ea typeface="Kantumruy Pro" pitchFamily="34" charset="-122"/>
+                <a:cs typeface="Kantumruy Pro" pitchFamily="34" charset="-120"/>
+              </a:rPr>
+              <a:t>Claude Code សរសេរ</a:t>
+            </a:r>
+            <a:endParaRPr lang="en-US" sz="2000" dirty="0"/>
+          </a:p>
+        </p:txBody>
+      </p:sp>
+      <p:sp>
+        <p:nvSpPr>
+          <p:cNvPr id="5" name="Shape 3"/>
+          <p:cNvSpPr/>
+          <p:nvPr/>
+        </p:nvSpPr>
+        <p:spPr>
+          <a:xfrm>
+            <a:off x="815975" y="2370386"/>
+            <a:ext cx="5124450" cy="596900"/>
+          </a:xfrm>
+          <a:prstGeom prst="roundRect">
+            <a:avLst>
+              <a:gd name="adj" fmla="val 16489"/>
+            </a:avLst>
+          </a:prstGeom>
+          <a:solidFill>
+            <a:srgbClr val="FFFDF7"/>
+          </a:solidFill>
+          <a:ln w="6350">
+            <a:solidFill>
+              <a:srgbClr val="E2DED2"/>
+            </a:solidFill>
+            <a:prstDash val="solid"/>
+          </a:ln>
+        </p:spPr>
+      </p:sp>
+      <p:sp>
+        <p:nvSpPr>
+          <p:cNvPr id="6" name="Text 4"/>
+          <p:cNvSpPr/>
+          <p:nvPr/>
+        </p:nvSpPr>
+        <p:spPr>
+          <a:xfrm>
+            <a:off x="1022350" y="2525961"/>
+            <a:ext cx="4853051" cy="311150"/>
+          </a:xfrm>
+          <a:prstGeom prst="rect">
+            <a:avLst/>
+          </a:prstGeom>
+          <a:noFill/>
+          <a:ln/>
+        </p:spPr>
+        <p:txBody>
+          <a:bodyPr wrap="square" lIns="0" tIns="0" rIns="0" bIns="0" rtlCol="0" anchor="t">
+            <a:normAutofit/>
+          </a:bodyPr>
+          <a:lstStyle/>
+          <a:p>
+            <a:pPr algn="l" indent="0" marL="0">
+              <a:lnSpc>
+                <a:spcPts val="2250"/>
+              </a:lnSpc>
+              <a:buNone/>
+            </a:pPr>
+            <a:r>
+              <a:rPr lang="en-US" sz="1500" b="1" dirty="0">
+                <a:solidFill>
+                  <a:srgbClr val="13202E"/>
+                </a:solidFill>
+                <a:latin typeface="Kantumruy Pro" pitchFamily="34" charset="0"/>
+                <a:ea typeface="Kantumruy Pro" pitchFamily="34" charset="-122"/>
+                <a:cs typeface="Kantumruy Pro" pitchFamily="34" charset="-120"/>
+              </a:rPr>
+              <a:t>DESIGN.md</a:t>
+            </a:r>
+            <a:r>
+              <a:rPr lang="en-US" sz="1500" dirty="0">
+                <a:solidFill>
+                  <a:srgbClr val="13202E"/>
+                </a:solidFill>
+                <a:latin typeface="Kantumruy Pro" pitchFamily="34" charset="0"/>
+                <a:ea typeface="Kantumruy Pro" pitchFamily="34" charset="-122"/>
+                <a:cs typeface="Kantumruy Pro" pitchFamily="34" charset="-120"/>
+              </a:rPr>
+              <a:t> — ច្បាប់ ៦ និងលំដាប់ពិនិត្យ</a:t>
+            </a:r>
+            <a:endParaRPr lang="en-US" sz="1500" dirty="0"/>
+          </a:p>
+        </p:txBody>
+      </p:sp>
+      <p:sp>
+        <p:nvSpPr>
+          <p:cNvPr id="7" name="Shape 5"/>
+          <p:cNvSpPr/>
+          <p:nvPr/>
+        </p:nvSpPr>
+        <p:spPr>
+          <a:xfrm>
+            <a:off x="815975" y="3075236"/>
+            <a:ext cx="5124450" cy="596900"/>
+          </a:xfrm>
+          <a:prstGeom prst="roundRect">
+            <a:avLst>
+              <a:gd name="adj" fmla="val 16489"/>
+            </a:avLst>
+          </a:prstGeom>
+          <a:solidFill>
+            <a:srgbClr val="FFFDF7"/>
+          </a:solidFill>
+          <a:ln w="6350">
+            <a:solidFill>
+              <a:srgbClr val="E2DED2"/>
+            </a:solidFill>
+            <a:prstDash val="solid"/>
+          </a:ln>
+        </p:spPr>
+      </p:sp>
+      <p:sp>
+        <p:nvSpPr>
+          <p:cNvPr id="8" name="Text 6"/>
+          <p:cNvSpPr/>
+          <p:nvPr/>
+        </p:nvSpPr>
+        <p:spPr>
+          <a:xfrm>
+            <a:off x="1022350" y="3230811"/>
+            <a:ext cx="4853051" cy="311150"/>
+          </a:xfrm>
+          <a:prstGeom prst="rect">
+            <a:avLst/>
+          </a:prstGeom>
+          <a:noFill/>
+          <a:ln/>
+        </p:spPr>
+        <p:txBody>
+          <a:bodyPr wrap="square" lIns="0" tIns="0" rIns="0" bIns="0" rtlCol="0" anchor="t">
+            <a:normAutofit/>
+          </a:bodyPr>
+          <a:lstStyle/>
+          <a:p>
+            <a:pPr algn="l" indent="0" marL="0">
+              <a:lnSpc>
+                <a:spcPts val="2250"/>
+              </a:lnSpc>
+              <a:buNone/>
+            </a:pPr>
+            <a:r>
+              <a:rPr lang="en-US" sz="1500" b="1" dirty="0">
+                <a:solidFill>
+                  <a:srgbClr val="13202E"/>
+                </a:solidFill>
+                <a:latin typeface="Kantumruy Pro" pitchFamily="34" charset="0"/>
+                <a:ea typeface="Kantumruy Pro" pitchFamily="34" charset="-122"/>
+                <a:cs typeface="Kantumruy Pro" pitchFamily="34" charset="-120"/>
+              </a:rPr>
+              <a:t>កូដ</a:t>
+            </a:r>
+            <a:r>
+              <a:rPr lang="en-US" sz="1500" dirty="0">
+                <a:solidFill>
+                  <a:srgbClr val="13202E"/>
+                </a:solidFill>
+                <a:latin typeface="Kantumruy Pro" pitchFamily="34" charset="0"/>
+                <a:ea typeface="Kantumruy Pro" pitchFamily="34" charset="-122"/>
+                <a:cs typeface="Kantumruy Pro" pitchFamily="34" charset="-120"/>
+              </a:rPr>
+              <a:t> — layers, security, error handling</a:t>
+            </a:r>
+            <a:endParaRPr lang="en-US" sz="1500" dirty="0"/>
+          </a:p>
+        </p:txBody>
+      </p:sp>
+      <p:sp>
+        <p:nvSpPr>
+          <p:cNvPr id="9" name="Shape 7"/>
+          <p:cNvSpPr/>
+          <p:nvPr/>
+        </p:nvSpPr>
+        <p:spPr>
+          <a:xfrm>
+            <a:off x="815975" y="3780086"/>
+            <a:ext cx="5124450" cy="596900"/>
+          </a:xfrm>
+          <a:prstGeom prst="roundRect">
+            <a:avLst>
+              <a:gd name="adj" fmla="val 16489"/>
+            </a:avLst>
+          </a:prstGeom>
+          <a:solidFill>
+            <a:srgbClr val="FFFDF7"/>
+          </a:solidFill>
+          <a:ln w="6350">
+            <a:solidFill>
+              <a:srgbClr val="E2DED2"/>
+            </a:solidFill>
+            <a:prstDash val="solid"/>
+          </a:ln>
+        </p:spPr>
+      </p:sp>
+      <p:sp>
+        <p:nvSpPr>
+          <p:cNvPr id="10" name="Text 8"/>
+          <p:cNvSpPr/>
+          <p:nvPr/>
+        </p:nvSpPr>
+        <p:spPr>
+          <a:xfrm>
+            <a:off x="1022350" y="3935661"/>
+            <a:ext cx="4853051" cy="311150"/>
+          </a:xfrm>
+          <a:prstGeom prst="rect">
+            <a:avLst/>
+          </a:prstGeom>
+          <a:noFill/>
+          <a:ln/>
+        </p:spPr>
+        <p:txBody>
+          <a:bodyPr wrap="square" lIns="0" tIns="0" rIns="0" bIns="0" rtlCol="0" anchor="t">
+            <a:normAutofit/>
+          </a:bodyPr>
+          <a:lstStyle/>
+          <a:p>
+            <a:pPr algn="l" indent="0" marL="0">
+              <a:lnSpc>
+                <a:spcPts val="2250"/>
+              </a:lnSpc>
+              <a:buNone/>
+            </a:pPr>
+            <a:r>
+              <a:rPr lang="en-US" sz="1500" b="1" dirty="0">
+                <a:solidFill>
+                  <a:srgbClr val="13202E"/>
+                </a:solidFill>
+                <a:latin typeface="Kantumruy Pro" pitchFamily="34" charset="0"/>
+                <a:ea typeface="Kantumruy Pro" pitchFamily="34" charset="-122"/>
+                <a:cs typeface="Kantumruy Pro" pitchFamily="34" charset="-120"/>
+              </a:rPr>
+              <a:t>Tests</a:t>
+            </a:r>
+            <a:r>
+              <a:rPr lang="en-US" sz="1500" dirty="0">
+                <a:solidFill>
+                  <a:srgbClr val="13202E"/>
+                </a:solidFill>
+                <a:latin typeface="Kantumruy Pro" pitchFamily="34" charset="0"/>
+                <a:ea typeface="Kantumruy Pro" pitchFamily="34" charset="-122"/>
+                <a:cs typeface="Kantumruy Pro" pitchFamily="34" charset="-120"/>
+              </a:rPr>
+              <a:t> — scenario និង concurrency</a:t>
+            </a:r>
+            <a:endParaRPr lang="en-US" sz="1500" dirty="0"/>
+          </a:p>
+        </p:txBody>
+      </p:sp>
+      <p:sp>
+        <p:nvSpPr>
+          <p:cNvPr id="11" name="Shape 9"/>
+          <p:cNvSpPr/>
+          <p:nvPr/>
+        </p:nvSpPr>
+        <p:spPr>
+          <a:xfrm>
+            <a:off x="815975" y="4484936"/>
+            <a:ext cx="5124450" cy="596900"/>
+          </a:xfrm>
+          <a:prstGeom prst="roundRect">
+            <a:avLst>
+              <a:gd name="adj" fmla="val 16489"/>
+            </a:avLst>
+          </a:prstGeom>
+          <a:solidFill>
+            <a:srgbClr val="FFFDF7"/>
+          </a:solidFill>
+          <a:ln w="6350">
+            <a:solidFill>
+              <a:srgbClr val="E2DED2"/>
+            </a:solidFill>
+            <a:prstDash val="solid"/>
+          </a:ln>
+        </p:spPr>
+      </p:sp>
+      <p:sp>
+        <p:nvSpPr>
+          <p:cNvPr id="12" name="Text 10"/>
+          <p:cNvSpPr/>
+          <p:nvPr/>
+        </p:nvSpPr>
+        <p:spPr>
+          <a:xfrm>
+            <a:off x="1022350" y="4640511"/>
+            <a:ext cx="4853051" cy="311150"/>
+          </a:xfrm>
+          <a:prstGeom prst="rect">
+            <a:avLst/>
+          </a:prstGeom>
+          <a:noFill/>
+          <a:ln/>
+        </p:spPr>
+        <p:txBody>
+          <a:bodyPr wrap="square" lIns="0" tIns="0" rIns="0" bIns="0" rtlCol="0" anchor="t">
+            <a:normAutofit/>
+          </a:bodyPr>
+          <a:lstStyle/>
+          <a:p>
+            <a:pPr algn="l" indent="0" marL="0">
+              <a:lnSpc>
+                <a:spcPts val="2250"/>
+              </a:lnSpc>
+              <a:buNone/>
+            </a:pPr>
+            <a:r>
+              <a:rPr lang="en-US" sz="1500" b="1" dirty="0">
+                <a:solidFill>
+                  <a:srgbClr val="13202E"/>
+                </a:solidFill>
+                <a:latin typeface="Kantumruy Pro" pitchFamily="34" charset="0"/>
+                <a:ea typeface="Kantumruy Pro" pitchFamily="34" charset="-122"/>
+                <a:cs typeface="Kantumruy Pro" pitchFamily="34" charset="-120"/>
+              </a:rPr>
+              <a:t>Docs</a:t>
+            </a:r>
+            <a:r>
+              <a:rPr lang="en-US" sz="1500" dirty="0">
+                <a:solidFill>
+                  <a:srgbClr val="13202E"/>
+                </a:solidFill>
+                <a:latin typeface="Kantumruy Pro" pitchFamily="34" charset="0"/>
+                <a:ea typeface="Kantumruy Pro" pitchFamily="34" charset="-122"/>
+                <a:cs typeface="Kantumruy Pro" pitchFamily="34" charset="-120"/>
+              </a:rPr>
+              <a:t> — README, Swagger, slides</a:t>
+            </a:r>
+            <a:endParaRPr lang="en-US" sz="1500" dirty="0"/>
+          </a:p>
+        </p:txBody>
+      </p:sp>
+      <p:sp>
+        <p:nvSpPr>
+          <p:cNvPr id="13" name="Text 11"/>
+          <p:cNvSpPr/>
+          <p:nvPr/>
+        </p:nvSpPr>
+        <p:spPr>
+          <a:xfrm>
+            <a:off x="6248400" y="1935411"/>
+            <a:ext cx="5284724" cy="355600"/>
+          </a:xfrm>
+          <a:prstGeom prst="rect">
+            <a:avLst/>
+          </a:prstGeom>
+          <a:noFill/>
+          <a:ln/>
+        </p:spPr>
+        <p:txBody>
+          <a:bodyPr wrap="square" lIns="0" tIns="0" rIns="0" bIns="0" rtlCol="0" anchor="t">
+            <a:normAutofit/>
+          </a:bodyPr>
+          <a:lstStyle/>
+          <a:p>
+            <a:pPr algn="l" indent="0" marL="0">
+              <a:lnSpc>
+                <a:spcPts val="2600"/>
+              </a:lnSpc>
+              <a:buNone/>
+            </a:pPr>
+            <a:r>
+              <a:rPr lang="en-US" sz="2000" b="1" dirty="0">
+                <a:solidFill>
+                  <a:srgbClr val="2E7A3C"/>
+                </a:solidFill>
+                <a:latin typeface="Kantumruy Pro" pitchFamily="34" charset="0"/>
+                <a:ea typeface="Kantumruy Pro" pitchFamily="34" charset="-122"/>
+                <a:cs typeface="Kantumruy Pro" pitchFamily="34" charset="-120"/>
+              </a:rPr>
+              <a:t>ខ្ញុំ ធ្វើ</a:t>
+            </a:r>
+            <a:endParaRPr lang="en-US" sz="2000" dirty="0"/>
+          </a:p>
+        </p:txBody>
+      </p:sp>
+      <p:sp>
+        <p:nvSpPr>
+          <p:cNvPr id="14" name="Shape 12"/>
+          <p:cNvSpPr/>
+          <p:nvPr/>
+        </p:nvSpPr>
+        <p:spPr>
+          <a:xfrm>
+            <a:off x="6248400" y="2367211"/>
+            <a:ext cx="5130800" cy="590550"/>
+          </a:xfrm>
+          <a:prstGeom prst="roundRect">
+            <a:avLst>
+              <a:gd name="adj" fmla="val 17204"/>
+            </a:avLst>
+          </a:prstGeom>
+          <a:solidFill>
+            <a:srgbClr val="13202E"/>
+          </a:solidFill>
+          <a:ln/>
+        </p:spPr>
+      </p:sp>
+      <p:sp>
+        <p:nvSpPr>
+          <p:cNvPr id="15" name="Text 13"/>
+          <p:cNvSpPr/>
+          <p:nvPr/>
+        </p:nvSpPr>
+        <p:spPr>
+          <a:xfrm>
+            <a:off x="6451600" y="2519611"/>
+            <a:ext cx="4866132" cy="311150"/>
+          </a:xfrm>
+          <a:prstGeom prst="rect">
+            <a:avLst/>
+          </a:prstGeom>
+          <a:noFill/>
+          <a:ln/>
+        </p:spPr>
+        <p:txBody>
+          <a:bodyPr wrap="square" lIns="0" tIns="0" rIns="0" bIns="0" rtlCol="0" anchor="t">
+            <a:normAutofit/>
+          </a:bodyPr>
+          <a:lstStyle/>
+          <a:p>
+            <a:pPr algn="l" indent="0" marL="0">
+              <a:lnSpc>
+                <a:spcPts val="2250"/>
+              </a:lnSpc>
+              <a:buNone/>
+            </a:pPr>
+            <a:r>
+              <a:rPr lang="en-US" sz="1500" b="1" dirty="0">
+                <a:solidFill>
+                  <a:srgbClr val="F5F3EC"/>
+                </a:solidFill>
+                <a:latin typeface="Kantumruy Pro" pitchFamily="34" charset="0"/>
+                <a:ea typeface="Kantumruy Pro" pitchFamily="34" charset="-122"/>
+                <a:cs typeface="Kantumruy Pro" pitchFamily="34" charset="-120"/>
+              </a:rPr>
+              <a:t>Requirement</a:t>
+            </a:r>
+            <a:r>
+              <a:rPr lang="en-US" sz="1500" dirty="0">
+                <a:solidFill>
+                  <a:srgbClr val="F5F3EC"/>
+                </a:solidFill>
+                <a:latin typeface="Kantumruy Pro" pitchFamily="34" charset="0"/>
+                <a:ea typeface="Kantumruy Pro" pitchFamily="34" charset="-122"/>
+                <a:cs typeface="Kantumruy Pro" pitchFamily="34" charset="-120"/>
+              </a:rPr>
+              <a:t> — ផ្តល់ច្បាប់ ឲ្យច្បាស់</a:t>
+            </a:r>
+            <a:endParaRPr lang="en-US" sz="1500" dirty="0"/>
+          </a:p>
+        </p:txBody>
+      </p:sp>
+      <p:sp>
+        <p:nvSpPr>
+          <p:cNvPr id="16" name="Shape 14"/>
+          <p:cNvSpPr/>
+          <p:nvPr/>
+        </p:nvSpPr>
+        <p:spPr>
+          <a:xfrm>
+            <a:off x="6248400" y="3059361"/>
+            <a:ext cx="5130800" cy="590550"/>
+          </a:xfrm>
+          <a:prstGeom prst="roundRect">
+            <a:avLst>
+              <a:gd name="adj" fmla="val 17204"/>
+            </a:avLst>
+          </a:prstGeom>
+          <a:solidFill>
+            <a:srgbClr val="13202E"/>
+          </a:solidFill>
+          <a:ln/>
+        </p:spPr>
+      </p:sp>
+      <p:sp>
+        <p:nvSpPr>
+          <p:cNvPr id="17" name="Text 15"/>
+          <p:cNvSpPr/>
+          <p:nvPr/>
+        </p:nvSpPr>
+        <p:spPr>
+          <a:xfrm>
+            <a:off x="6451600" y="3211761"/>
+            <a:ext cx="4866132" cy="311150"/>
+          </a:xfrm>
+          <a:prstGeom prst="rect">
+            <a:avLst/>
+          </a:prstGeom>
+          <a:noFill/>
+          <a:ln/>
+        </p:spPr>
+        <p:txBody>
+          <a:bodyPr wrap="square" lIns="0" tIns="0" rIns="0" bIns="0" rtlCol="0" anchor="t">
+            <a:normAutofit/>
+          </a:bodyPr>
+          <a:lstStyle/>
+          <a:p>
+            <a:pPr algn="l" indent="0" marL="0">
+              <a:lnSpc>
+                <a:spcPts val="2250"/>
+              </a:lnSpc>
+              <a:buNone/>
+            </a:pPr>
+            <a:r>
+              <a:rPr lang="en-US" sz="1500" b="1" dirty="0">
+                <a:solidFill>
+                  <a:srgbClr val="F5F3EC"/>
+                </a:solidFill>
+                <a:latin typeface="Kantumruy Pro" pitchFamily="34" charset="0"/>
+                <a:ea typeface="Kantumruy Pro" pitchFamily="34" charset="-122"/>
+                <a:cs typeface="Kantumruy Pro" pitchFamily="34" charset="-120"/>
+              </a:rPr>
+              <a:t>Review</a:t>
+            </a:r>
+            <a:r>
+              <a:rPr lang="en-US" sz="1500" dirty="0">
+                <a:solidFill>
+                  <a:srgbClr val="F5F3EC"/>
+                </a:solidFill>
+                <a:latin typeface="Kantumruy Pro" pitchFamily="34" charset="0"/>
+                <a:ea typeface="Kantumruy Pro" pitchFamily="34" charset="-122"/>
+                <a:cs typeface="Kantumruy Pro" pitchFamily="34" charset="-120"/>
+              </a:rPr>
+              <a:t> — design មុន, diff ក្រោយ</a:t>
+            </a:r>
+            <a:endParaRPr lang="en-US" sz="1500" dirty="0"/>
+          </a:p>
+        </p:txBody>
+      </p:sp>
+      <p:sp>
+        <p:nvSpPr>
+          <p:cNvPr id="18" name="Shape 16"/>
+          <p:cNvSpPr/>
+          <p:nvPr/>
+        </p:nvSpPr>
+        <p:spPr>
+          <a:xfrm>
+            <a:off x="6248400" y="3751511"/>
+            <a:ext cx="5130800" cy="590550"/>
+          </a:xfrm>
+          <a:prstGeom prst="roundRect">
+            <a:avLst>
+              <a:gd name="adj" fmla="val 17204"/>
+            </a:avLst>
+          </a:prstGeom>
+          <a:solidFill>
+            <a:srgbClr val="13202E"/>
+          </a:solidFill>
+          <a:ln/>
+        </p:spPr>
+      </p:sp>
+      <p:sp>
+        <p:nvSpPr>
+          <p:cNvPr id="19" name="Text 17"/>
+          <p:cNvSpPr/>
+          <p:nvPr/>
+        </p:nvSpPr>
+        <p:spPr>
+          <a:xfrm>
+            <a:off x="6451600" y="3903911"/>
+            <a:ext cx="4866132" cy="311150"/>
+          </a:xfrm>
+          <a:prstGeom prst="rect">
+            <a:avLst/>
+          </a:prstGeom>
+          <a:noFill/>
+          <a:ln/>
+        </p:spPr>
+        <p:txBody>
+          <a:bodyPr wrap="square" lIns="0" tIns="0" rIns="0" bIns="0" rtlCol="0" anchor="t">
+            <a:normAutofit/>
+          </a:bodyPr>
+          <a:lstStyle/>
+          <a:p>
+            <a:pPr algn="l" indent="0" marL="0">
+              <a:lnSpc>
+                <a:spcPts val="2250"/>
+              </a:lnSpc>
+              <a:buNone/>
+            </a:pPr>
+            <a:r>
+              <a:rPr lang="en-US" sz="1500" b="1" dirty="0">
+                <a:solidFill>
+                  <a:srgbClr val="F5F3EC"/>
+                </a:solidFill>
+                <a:latin typeface="Kantumruy Pro" pitchFamily="34" charset="0"/>
+                <a:ea typeface="Kantumruy Pro" pitchFamily="34" charset="-122"/>
+                <a:cs typeface="Kantumruy Pro" pitchFamily="34" charset="-120"/>
+              </a:rPr>
+              <a:t>ផ្ទៀងផ្ទាត់</a:t>
+            </a:r>
+            <a:r>
+              <a:rPr lang="en-US" sz="1500" dirty="0">
+                <a:solidFill>
+                  <a:srgbClr val="F5F3EC"/>
+                </a:solidFill>
+                <a:latin typeface="Kantumruy Pro" pitchFamily="34" charset="0"/>
+                <a:ea typeface="Kantumruy Pro" pitchFamily="34" charset="-122"/>
+                <a:cs typeface="Kantumruy Pro" pitchFamily="34" charset="-120"/>
+              </a:rPr>
+              <a:t> — ./gradlew test 20/20</a:t>
+            </a:r>
+            <a:endParaRPr lang="en-US" sz="1500" dirty="0"/>
+          </a:p>
+        </p:txBody>
+      </p:sp>
+      <p:sp>
+        <p:nvSpPr>
+          <p:cNvPr id="20" name="Shape 18"/>
+          <p:cNvSpPr/>
+          <p:nvPr/>
+        </p:nvSpPr>
+        <p:spPr>
+          <a:xfrm>
+            <a:off x="6248400" y="4443661"/>
+            <a:ext cx="5130800" cy="590550"/>
+          </a:xfrm>
+          <a:prstGeom prst="roundRect">
+            <a:avLst>
+              <a:gd name="adj" fmla="val 17204"/>
+            </a:avLst>
+          </a:prstGeom>
+          <a:solidFill>
+            <a:srgbClr val="13202E"/>
+          </a:solidFill>
+          <a:ln/>
+        </p:spPr>
+      </p:sp>
+      <p:sp>
+        <p:nvSpPr>
+          <p:cNvPr id="21" name="Text 19"/>
+          <p:cNvSpPr/>
+          <p:nvPr/>
+        </p:nvSpPr>
+        <p:spPr>
+          <a:xfrm>
+            <a:off x="6451600" y="4596061"/>
+            <a:ext cx="4866132" cy="311150"/>
+          </a:xfrm>
+          <a:prstGeom prst="rect">
+            <a:avLst/>
+          </a:prstGeom>
+          <a:noFill/>
+          <a:ln/>
+        </p:spPr>
+        <p:txBody>
+          <a:bodyPr wrap="square" lIns="0" tIns="0" rIns="0" bIns="0" rtlCol="0" anchor="t">
+            <a:normAutofit/>
+          </a:bodyPr>
+          <a:lstStyle/>
+          <a:p>
+            <a:pPr algn="l" indent="0" marL="0">
+              <a:lnSpc>
+                <a:spcPts val="2250"/>
+              </a:lnSpc>
+              <a:buNone/>
+            </a:pPr>
+            <a:r>
+              <a:rPr lang="en-US" sz="1500" b="1" dirty="0">
+                <a:solidFill>
+                  <a:srgbClr val="F5F3EC"/>
+                </a:solidFill>
+                <a:latin typeface="Kantumruy Pro" pitchFamily="34" charset="0"/>
+                <a:ea typeface="Kantumruy Pro" pitchFamily="34" charset="-122"/>
+                <a:cs typeface="Kantumruy Pro" pitchFamily="34" charset="-120"/>
+              </a:rPr>
+              <a:t>សម្រេចចិត្ត</a:t>
+            </a:r>
+            <a:r>
+              <a:rPr lang="en-US" sz="1500" dirty="0">
+                <a:solidFill>
+                  <a:srgbClr val="F5F3EC"/>
+                </a:solidFill>
+                <a:latin typeface="Kantumruy Pro" pitchFamily="34" charset="0"/>
+                <a:ea typeface="Kantumruy Pro" pitchFamily="34" charset="-122"/>
+                <a:cs typeface="Kantumruy Pro" pitchFamily="34" charset="-120"/>
+              </a:rPr>
+              <a:t> — commit និង merge</a:t>
+            </a:r>
+            <a:endParaRPr lang="en-US" sz="1500" dirty="0"/>
+          </a:p>
+        </p:txBody>
+      </p:sp>
+      <p:sp>
+        <p:nvSpPr>
+          <p:cNvPr id="22" name="Text 20"/>
+          <p:cNvSpPr/>
+          <p:nvPr/>
+        </p:nvSpPr>
+        <p:spPr>
+          <a:xfrm>
+            <a:off x="812800" y="5389811"/>
+            <a:ext cx="10883392" cy="254000"/>
+          </a:xfrm>
+          <a:prstGeom prst="rect">
+            <a:avLst/>
+          </a:prstGeom>
+          <a:noFill/>
+          <a:ln/>
+        </p:spPr>
+        <p:txBody>
+          <a:bodyPr wrap="square" lIns="0" tIns="0" rIns="0" bIns="0" rtlCol="0" anchor="t">
+            <a:normAutofit/>
+          </a:bodyPr>
+          <a:lstStyle/>
+          <a:p>
+            <a:pPr algn="l" indent="0" marL="0">
+              <a:lnSpc>
+                <a:spcPts val="1800"/>
+              </a:lnSpc>
+              <a:buNone/>
+            </a:pPr>
+            <a:r>
+              <a:rPr lang="en-US" sz="1200" dirty="0">
+                <a:solidFill>
+                  <a:srgbClr val="4A5361"/>
+                </a:solidFill>
+                <a:latin typeface="Kantumruy Pro" pitchFamily="34" charset="0"/>
+                <a:ea typeface="Kantumruy Pro" pitchFamily="34" charset="-122"/>
+                <a:cs typeface="Kantumruy Pro" pitchFamily="34" charset="-120"/>
+              </a:rPr>
+              <a:t>គ្រប់ commit មាន </a:t>
+            </a:r>
+            <a:r>
+              <a:rPr lang="en-US" sz="1200" dirty="0">
+                <a:solidFill>
+                  <a:srgbClr val="13202E"/>
+                </a:solidFill>
+                <a:latin typeface="Kantumruy Pro" pitchFamily="34" charset="0"/>
+                <a:ea typeface="Kantumruy Pro" pitchFamily="34" charset="-122"/>
+                <a:cs typeface="Kantumruy Pro" pitchFamily="34" charset="-120"/>
+              </a:rPr>
+              <a:t>Co-Authored-By: Claude</a:t>
+            </a:r>
+            <a:r>
+              <a:rPr lang="en-US" sz="1200" dirty="0">
+                <a:solidFill>
+                  <a:srgbClr val="4A5361"/>
+                </a:solidFill>
+                <a:latin typeface="Kantumruy Pro" pitchFamily="34" charset="0"/>
+                <a:ea typeface="Kantumruy Pro" pitchFamily="34" charset="-122"/>
+                <a:cs typeface="Kantumruy Pro" pitchFamily="34" charset="-120"/>
+              </a:rPr>
+              <a:t> — បង្ហាញច្បាស់ ថា AI បានជួយ</a:t>
+            </a:r>
+            <a:endParaRPr lang="en-US" sz="1200" dirty="0"/>
+          </a:p>
+        </p:txBody>
+      </p:sp>
+    </p:spTree>
+  </p:cSld>
+  <p:clrMapOvr>
+    <a:masterClrMapping/>
+  </p:clrMapOvr>
+</p:sld>
+</file>
+
+<file path=ppt/slides/slide14.xml><?xml version="1.0" encoding="utf-8"?>
+<p:sld xmlns:a="http://schemas.openxmlformats.org/drawingml/2006/main" xmlns:r="http://schemas.openxmlformats.org/officeDocument/2006/relationships" xmlns:p="http://schemas.openxmlformats.org/presentationml/2006/main">
+  <p:cSld name="Slide 14">
     <p:bg>
       <p:bgPr>
         <a:solidFill>
@@ -3826,7 +6128,7 @@
         <p:spPr>
           <a:xfrm>
             <a:off x="812800" y="812800"/>
-            <a:ext cx="10883392" cy="238760"/>
+            <a:ext cx="10883392" cy="238720"/>
           </a:xfrm>
           <a:prstGeom prst="rect">
             <a:avLst/>
@@ -3869,8 +6171,8 @@
         </p:nvSpPr>
         <p:spPr>
           <a:xfrm>
-            <a:off x="812800" y="1102364"/>
-            <a:ext cx="10883392" cy="553720"/>
+            <a:off x="812800" y="1102320"/>
+            <a:ext cx="10883392" cy="553690"/>
           </a:xfrm>
           <a:prstGeom prst="rect">
             <a:avLst/>
@@ -3913,8 +6215,8 @@
         </p:nvSpPr>
         <p:spPr>
           <a:xfrm>
-            <a:off x="812800" y="1935479"/>
-            <a:ext cx="558800" cy="553720"/>
+            <a:off x="812800" y="1935411"/>
+            <a:ext cx="558800" cy="553690"/>
           </a:xfrm>
           <a:prstGeom prst="rect">
             <a:avLst/>
@@ -3957,7 +6259,7 @@
         </p:nvSpPr>
         <p:spPr>
           <a:xfrm>
-            <a:off x="1574800" y="2009142"/>
+            <a:off x="1574800" y="2009031"/>
             <a:ext cx="10098532" cy="406400"/>
           </a:xfrm>
           <a:prstGeom prst="rect">
@@ -4012,8 +6314,8 @@
         </p:nvSpPr>
         <p:spPr>
           <a:xfrm>
-            <a:off x="812800" y="2717800"/>
-            <a:ext cx="558800" cy="553720"/>
+            <a:off x="812800" y="2717701"/>
+            <a:ext cx="558800" cy="553690"/>
           </a:xfrm>
           <a:prstGeom prst="rect">
             <a:avLst/>
@@ -4056,7 +6358,7 @@
         </p:nvSpPr>
         <p:spPr>
           <a:xfrm>
-            <a:off x="1574800" y="2791464"/>
+            <a:off x="1574800" y="2791321"/>
             <a:ext cx="10098532" cy="406400"/>
           </a:xfrm>
           <a:prstGeom prst="rect">
@@ -4111,8 +6413,8 @@
         </p:nvSpPr>
         <p:spPr>
           <a:xfrm>
-            <a:off x="812800" y="3500121"/>
-            <a:ext cx="558800" cy="553720"/>
+            <a:off x="812800" y="3499991"/>
+            <a:ext cx="558800" cy="553690"/>
           </a:xfrm>
           <a:prstGeom prst="rect">
             <a:avLst/>
@@ -4155,7 +6457,7 @@
         </p:nvSpPr>
         <p:spPr>
           <a:xfrm>
-            <a:off x="1574800" y="3573779"/>
+            <a:off x="1574800" y="3573611"/>
             <a:ext cx="10098532" cy="406400"/>
           </a:xfrm>
           <a:prstGeom prst="rect">
@@ -4210,9 +6512,9 @@
 </p:sld>
 </file>
 
-<file path=ppt/slides/slide13.xml><?xml version="1.0" encoding="utf-8"?>
+<file path=ppt/slides/slide15.xml><?xml version="1.0" encoding="utf-8"?>
 <p:sld xmlns:a="http://schemas.openxmlformats.org/drawingml/2006/main" xmlns:r="http://schemas.openxmlformats.org/officeDocument/2006/relationships" xmlns:p="http://schemas.openxmlformats.org/presentationml/2006/main">
-  <p:cSld name="Slide 13">
+  <p:cSld name="Slide 15">
     <p:bg>
       <p:bgPr>
         <a:solidFill>
@@ -4243,7 +6545,7 @@
         <p:spPr>
           <a:xfrm>
             <a:off x="812800" y="812800"/>
-            <a:ext cx="10883392" cy="238760"/>
+            <a:ext cx="10883392" cy="238720"/>
           </a:xfrm>
           <a:prstGeom prst="rect">
             <a:avLst/>
@@ -4286,8 +6588,8 @@
         </p:nvSpPr>
         <p:spPr>
           <a:xfrm>
-            <a:off x="812800" y="1102364"/>
-            <a:ext cx="10883392" cy="553720"/>
+            <a:off x="812800" y="1102320"/>
+            <a:ext cx="10883392" cy="553690"/>
           </a:xfrm>
           <a:prstGeom prst="rect">
             <a:avLst/>
@@ -4337,8 +6639,8 @@
           </p:nvPr>
         </p:nvGraphicFramePr>
         <p:xfrm>
-          <a:off x="825500" y="1948179"/>
-          <a:ext cx="10553700" cy="1797050"/>
+          <a:off x="825500" y="1948111"/>
+          <a:ext cx="10553700" cy="1796604"/>
         </p:xfrm>
         <a:graphic>
           <a:graphicData uri="http://schemas.openxmlformats.org/drawingml/2006/table">
@@ -4348,7 +6650,7 @@
                 <a:gridCol w="6754368"/>
                 <a:gridCol w="3799332"/>
               </a:tblGrid>
-              <a:tr h="359410">
+              <a:tr h="359321">
                 <a:tc>
                   <a:txBody>
                     <a:bodyPr/>
@@ -4492,7 +6794,7 @@
                   </a:tcPr>
                 </a:tc>
               </a:tr>
-              <a:tr h="359410">
+              <a:tr h="359321">
                 <a:tc>
                   <a:txBody>
                     <a:bodyPr/>
@@ -4630,7 +6932,7 @@
                   </a:tcPr>
                 </a:tc>
               </a:tr>
-              <a:tr h="359410">
+              <a:tr h="359321">
                 <a:tc>
                   <a:txBody>
                     <a:bodyPr/>
@@ -4768,7 +7070,7 @@
                   </a:tcPr>
                 </a:tc>
               </a:tr>
-              <a:tr h="359410">
+              <a:tr h="359321">
                 <a:tc>
                   <a:txBody>
                     <a:bodyPr/>
@@ -4906,7 +7208,7 @@
                   </a:tcPr>
                 </a:tc>
               </a:tr>
-              <a:tr h="359410">
+              <a:tr h="359321">
                 <a:tc>
                   <a:txBody>
                     <a:bodyPr/>
@@ -5056,8 +7358,8 @@
         </p:nvSpPr>
         <p:spPr>
           <a:xfrm>
-            <a:off x="812800" y="6238242"/>
-            <a:ext cx="10883392" cy="238760"/>
+            <a:off x="812800" y="6238280"/>
+            <a:ext cx="10883392" cy="238720"/>
           </a:xfrm>
           <a:prstGeom prst="rect">
             <a:avLst/>
@@ -5100,9 +7402,9 @@
 </p:sld>
 </file>
 
-<file path=ppt/slides/slide14.xml><?xml version="1.0" encoding="utf-8"?>
+<file path=ppt/slides/slide16.xml><?xml version="1.0" encoding="utf-8"?>
 <p:sld xmlns:a="http://schemas.openxmlformats.org/drawingml/2006/main" xmlns:r="http://schemas.openxmlformats.org/officeDocument/2006/relationships" xmlns:p="http://schemas.openxmlformats.org/presentationml/2006/main">
-  <p:cSld name="Slide 14">
+  <p:cSld name="Slide 16">
     <p:bg>
       <p:bgPr>
         <a:solidFill>
@@ -5132,7 +7434,7 @@
         </p:nvSpPr>
         <p:spPr>
           <a:xfrm>
-            <a:off x="812800" y="2466342"/>
+            <a:off x="812800" y="2466330"/>
             <a:ext cx="10883392" cy="1016000"/>
           </a:xfrm>
           <a:prstGeom prst="rect">
@@ -5176,8 +7478,8 @@
         </p:nvSpPr>
         <p:spPr>
           <a:xfrm>
-            <a:off x="812800" y="3660142"/>
-            <a:ext cx="10883392" cy="553720"/>
+            <a:off x="812800" y="3660130"/>
+            <a:ext cx="10883392" cy="553690"/>
           </a:xfrm>
           <a:prstGeom prst="rect">
             <a:avLst/>
@@ -5220,8 +7522,8 @@
         </p:nvSpPr>
         <p:spPr>
           <a:xfrm>
-            <a:off x="812800" y="6238242"/>
-            <a:ext cx="10883392" cy="238760"/>
+            <a:off x="812800" y="6238280"/>
+            <a:ext cx="10883392" cy="238720"/>
           </a:xfrm>
           <a:prstGeom prst="rect">
             <a:avLst/>
@@ -5297,7 +7599,7 @@
         <p:spPr>
           <a:xfrm>
             <a:off x="812800" y="812800"/>
-            <a:ext cx="10883392" cy="238760"/>
+            <a:ext cx="10883392" cy="238720"/>
           </a:xfrm>
           <a:prstGeom prst="rect">
             <a:avLst/>
@@ -5340,8 +7642,8 @@
         </p:nvSpPr>
         <p:spPr>
           <a:xfrm>
-            <a:off x="812800" y="1102360"/>
-            <a:ext cx="10883392" cy="553720"/>
+            <a:off x="812800" y="1102320"/>
+            <a:ext cx="10883392" cy="553690"/>
           </a:xfrm>
           <a:prstGeom prst="rect">
             <a:avLst/>
@@ -5384,12 +7686,12 @@
         </p:nvSpPr>
         <p:spPr>
           <a:xfrm>
-            <a:off x="815975" y="1938655"/>
-            <a:ext cx="3380303" cy="1677670"/>
+            <a:off x="815975" y="1938586"/>
+            <a:ext cx="3380284" cy="1680170"/>
           </a:xfrm>
           <a:prstGeom prst="roundRect">
             <a:avLst>
-              <a:gd name="adj" fmla="val 5867"/>
+              <a:gd name="adj" fmla="val 5858"/>
             </a:avLst>
           </a:prstGeom>
           <a:solidFill>
@@ -5411,8 +7713,8 @@
         </p:nvSpPr>
         <p:spPr>
           <a:xfrm>
-            <a:off x="1021080" y="2143760"/>
-            <a:ext cx="3059196" cy="238760"/>
+            <a:off x="1022350" y="2144961"/>
+            <a:ext cx="3056560" cy="238720"/>
           </a:xfrm>
           <a:prstGeom prst="rect">
             <a:avLst/>
@@ -5455,8 +7757,8 @@
         </p:nvSpPr>
         <p:spPr>
           <a:xfrm>
-            <a:off x="1021080" y="2433320"/>
-            <a:ext cx="3059196" cy="355600"/>
+            <a:off x="1022350" y="2434481"/>
+            <a:ext cx="3056560" cy="355600"/>
           </a:xfrm>
           <a:prstGeom prst="rect">
             <a:avLst/>
@@ -5499,8 +7801,8 @@
         </p:nvSpPr>
         <p:spPr>
           <a:xfrm>
-            <a:off x="1021080" y="2839720"/>
-            <a:ext cx="3059196" cy="596900"/>
+            <a:off x="1022350" y="2840881"/>
+            <a:ext cx="3056560" cy="596900"/>
           </a:xfrm>
           <a:prstGeom prst="rect">
             <a:avLst/>
@@ -5543,12 +7845,12 @@
         </p:nvSpPr>
         <p:spPr>
           <a:xfrm>
-            <a:off x="4405828" y="1938655"/>
-            <a:ext cx="3380303" cy="1677670"/>
+            <a:off x="4405809" y="1938586"/>
+            <a:ext cx="3380333" cy="1680170"/>
           </a:xfrm>
           <a:prstGeom prst="roundRect">
             <a:avLst>
-              <a:gd name="adj" fmla="val 5867"/>
+              <a:gd name="adj" fmla="val 5858"/>
             </a:avLst>
           </a:prstGeom>
           <a:solidFill>
@@ -5570,8 +7872,8 @@
         </p:nvSpPr>
         <p:spPr>
           <a:xfrm>
-            <a:off x="4610934" y="2143760"/>
-            <a:ext cx="3059196" cy="238760"/>
+            <a:off x="4612184" y="2144961"/>
+            <a:ext cx="3056611" cy="238720"/>
           </a:xfrm>
           <a:prstGeom prst="rect">
             <a:avLst/>
@@ -5614,8 +7916,8 @@
         </p:nvSpPr>
         <p:spPr>
           <a:xfrm>
-            <a:off x="4610934" y="2433320"/>
-            <a:ext cx="3059196" cy="355600"/>
+            <a:off x="4612184" y="2434481"/>
+            <a:ext cx="3056611" cy="355600"/>
           </a:xfrm>
           <a:prstGeom prst="rect">
             <a:avLst/>
@@ -5658,8 +7960,8 @@
         </p:nvSpPr>
         <p:spPr>
           <a:xfrm>
-            <a:off x="4610934" y="2839720"/>
-            <a:ext cx="3059196" cy="596900"/>
+            <a:off x="4612184" y="2840881"/>
+            <a:ext cx="3056611" cy="596900"/>
           </a:xfrm>
           <a:prstGeom prst="rect">
             <a:avLst/>
@@ -5702,12 +8004,12 @@
         </p:nvSpPr>
         <p:spPr>
           <a:xfrm>
-            <a:off x="7995682" y="1938655"/>
-            <a:ext cx="3380343" cy="1677670"/>
+            <a:off x="7995692" y="1938586"/>
+            <a:ext cx="3380284" cy="1680170"/>
           </a:xfrm>
           <a:prstGeom prst="roundRect">
             <a:avLst>
-              <a:gd name="adj" fmla="val 5867"/>
+              <a:gd name="adj" fmla="val 5858"/>
             </a:avLst>
           </a:prstGeom>
           <a:solidFill>
@@ -5729,8 +8031,8 @@
         </p:nvSpPr>
         <p:spPr>
           <a:xfrm>
-            <a:off x="8200787" y="2143760"/>
-            <a:ext cx="3059237" cy="238760"/>
+            <a:off x="8202067" y="2144961"/>
+            <a:ext cx="3056560" cy="238720"/>
           </a:xfrm>
           <a:prstGeom prst="rect">
             <a:avLst/>
@@ -5773,8 +8075,8 @@
         </p:nvSpPr>
         <p:spPr>
           <a:xfrm>
-            <a:off x="8200787" y="2433320"/>
-            <a:ext cx="3059237" cy="355600"/>
+            <a:off x="8202067" y="2434481"/>
+            <a:ext cx="3056560" cy="355600"/>
           </a:xfrm>
           <a:prstGeom prst="rect">
             <a:avLst/>
@@ -5817,8 +8119,8 @@
         </p:nvSpPr>
         <p:spPr>
           <a:xfrm>
-            <a:off x="8200787" y="2839720"/>
-            <a:ext cx="3059237" cy="596900"/>
+            <a:off x="8202067" y="2840881"/>
+            <a:ext cx="3056560" cy="596900"/>
           </a:xfrm>
           <a:prstGeom prst="rect">
             <a:avLst/>
@@ -5861,12 +8163,12 @@
         </p:nvSpPr>
         <p:spPr>
           <a:xfrm>
-            <a:off x="815975" y="3825875"/>
-            <a:ext cx="3380303" cy="2007870"/>
+            <a:off x="815975" y="3828306"/>
+            <a:ext cx="3380284" cy="2010370"/>
           </a:xfrm>
           <a:prstGeom prst="roundRect">
             <a:avLst>
-              <a:gd name="adj" fmla="val 4902"/>
+              <a:gd name="adj" fmla="val 4896"/>
             </a:avLst>
           </a:prstGeom>
           <a:solidFill>
@@ -5888,8 +8190,8 @@
         </p:nvSpPr>
         <p:spPr>
           <a:xfrm>
-            <a:off x="1021080" y="4030980"/>
-            <a:ext cx="3059196" cy="238760"/>
+            <a:off x="1022350" y="4034681"/>
+            <a:ext cx="3056560" cy="238720"/>
           </a:xfrm>
           <a:prstGeom prst="rect">
             <a:avLst/>
@@ -5932,8 +8234,8 @@
         </p:nvSpPr>
         <p:spPr>
           <a:xfrm>
-            <a:off x="1021080" y="4320540"/>
-            <a:ext cx="3059196" cy="355600"/>
+            <a:off x="1022350" y="4324201"/>
+            <a:ext cx="3056560" cy="355600"/>
           </a:xfrm>
           <a:prstGeom prst="rect">
             <a:avLst/>
@@ -5976,8 +8278,8 @@
         </p:nvSpPr>
         <p:spPr>
           <a:xfrm>
-            <a:off x="1021080" y="4726940"/>
-            <a:ext cx="3059196" cy="596900"/>
+            <a:off x="1022350" y="4730601"/>
+            <a:ext cx="3056560" cy="596900"/>
           </a:xfrm>
           <a:prstGeom prst="rect">
             <a:avLst/>
@@ -6020,12 +8322,12 @@
         </p:nvSpPr>
         <p:spPr>
           <a:xfrm>
-            <a:off x="4405828" y="3825875"/>
-            <a:ext cx="3380303" cy="2007870"/>
+            <a:off x="4405809" y="3828306"/>
+            <a:ext cx="3380333" cy="2010370"/>
           </a:xfrm>
           <a:prstGeom prst="roundRect">
             <a:avLst>
-              <a:gd name="adj" fmla="val 4902"/>
+              <a:gd name="adj" fmla="val 4896"/>
             </a:avLst>
           </a:prstGeom>
           <a:solidFill>
@@ -6047,8 +8349,8 @@
         </p:nvSpPr>
         <p:spPr>
           <a:xfrm>
-            <a:off x="4610934" y="4030980"/>
-            <a:ext cx="3059196" cy="238760"/>
+            <a:off x="4612184" y="4034681"/>
+            <a:ext cx="3056611" cy="238720"/>
           </a:xfrm>
           <a:prstGeom prst="rect">
             <a:avLst/>
@@ -6091,8 +8393,8 @@
         </p:nvSpPr>
         <p:spPr>
           <a:xfrm>
-            <a:off x="4610934" y="4320540"/>
-            <a:ext cx="3059196" cy="685800"/>
+            <a:off x="4612184" y="4324201"/>
+            <a:ext cx="3056611" cy="685800"/>
           </a:xfrm>
           <a:prstGeom prst="rect">
             <a:avLst/>
@@ -6135,8 +8437,8 @@
         </p:nvSpPr>
         <p:spPr>
           <a:xfrm>
-            <a:off x="4610934" y="5057140"/>
-            <a:ext cx="3059196" cy="596900"/>
+            <a:off x="4612184" y="5060801"/>
+            <a:ext cx="3056611" cy="596900"/>
           </a:xfrm>
           <a:prstGeom prst="rect">
             <a:avLst/>
@@ -6179,12 +8481,12 @@
         </p:nvSpPr>
         <p:spPr>
           <a:xfrm>
-            <a:off x="7995682" y="3825875"/>
-            <a:ext cx="3380343" cy="2007870"/>
+            <a:off x="7995692" y="3828306"/>
+            <a:ext cx="3380284" cy="2010370"/>
           </a:xfrm>
           <a:prstGeom prst="roundRect">
             <a:avLst>
-              <a:gd name="adj" fmla="val 4902"/>
+              <a:gd name="adj" fmla="val 4896"/>
             </a:avLst>
           </a:prstGeom>
           <a:solidFill>
@@ -6206,8 +8508,8 @@
         </p:nvSpPr>
         <p:spPr>
           <a:xfrm>
-            <a:off x="8200787" y="4030980"/>
-            <a:ext cx="3059237" cy="238760"/>
+            <a:off x="8202067" y="4034681"/>
+            <a:ext cx="3056560" cy="238720"/>
           </a:xfrm>
           <a:prstGeom prst="rect">
             <a:avLst/>
@@ -6250,8 +8552,8 @@
         </p:nvSpPr>
         <p:spPr>
           <a:xfrm>
-            <a:off x="8200787" y="4320540"/>
-            <a:ext cx="3059237" cy="355600"/>
+            <a:off x="8202067" y="4324201"/>
+            <a:ext cx="3056560" cy="355600"/>
           </a:xfrm>
           <a:prstGeom prst="rect">
             <a:avLst/>
@@ -6294,8 +8596,8 @@
         </p:nvSpPr>
         <p:spPr>
           <a:xfrm>
-            <a:off x="8200787" y="4726940"/>
-            <a:ext cx="3059237" cy="596900"/>
+            <a:off x="8202067" y="4730601"/>
+            <a:ext cx="3056560" cy="596900"/>
           </a:xfrm>
           <a:prstGeom prst="rect">
             <a:avLst/>
@@ -6371,7 +8673,7 @@
         <p:spPr>
           <a:xfrm>
             <a:off x="812800" y="812800"/>
-            <a:ext cx="10883392" cy="238760"/>
+            <a:ext cx="10883392" cy="238720"/>
           </a:xfrm>
           <a:prstGeom prst="rect">
             <a:avLst/>
@@ -6414,8 +8716,8 @@
         </p:nvSpPr>
         <p:spPr>
           <a:xfrm>
-            <a:off x="812800" y="1102361"/>
-            <a:ext cx="10883392" cy="553720"/>
+            <a:off x="812800" y="1102320"/>
+            <a:ext cx="10883392" cy="553690"/>
           </a:xfrm>
           <a:prstGeom prst="rect">
             <a:avLst/>
@@ -6465,7 +8767,7 @@
           </p:nvPr>
         </p:nvGraphicFramePr>
         <p:xfrm>
-          <a:off x="825500" y="1948180"/>
+          <a:off x="825500" y="1948111"/>
           <a:ext cx="10553700" cy="3302000"/>
         </p:xfrm>
         <a:graphic>
@@ -7649,7 +9951,7 @@
         <p:spPr>
           <a:xfrm>
             <a:off x="812800" y="812800"/>
-            <a:ext cx="10883392" cy="238760"/>
+            <a:ext cx="10883392" cy="238720"/>
           </a:xfrm>
           <a:prstGeom prst="rect">
             <a:avLst/>
@@ -7692,8 +9994,8 @@
         </p:nvSpPr>
         <p:spPr>
           <a:xfrm>
-            <a:off x="812800" y="1102361"/>
-            <a:ext cx="10883392" cy="553720"/>
+            <a:off x="812800" y="1102320"/>
+            <a:ext cx="10883392" cy="553690"/>
           </a:xfrm>
           <a:prstGeom prst="rect">
             <a:avLst/>
@@ -7736,12 +10038,12 @@
         </p:nvSpPr>
         <p:spPr>
           <a:xfrm>
-            <a:off x="815975" y="2040255"/>
-            <a:ext cx="1741170" cy="1379220"/>
+            <a:off x="815975" y="2040186"/>
+            <a:ext cx="1741140" cy="1381720"/>
           </a:xfrm>
           <a:prstGeom prst="roundRect">
             <a:avLst>
-              <a:gd name="adj" fmla="val 7136"/>
+              <a:gd name="adj" fmla="val 7123"/>
             </a:avLst>
           </a:prstGeom>
           <a:solidFill>
@@ -7763,8 +10065,8 @@
         </p:nvSpPr>
         <p:spPr>
           <a:xfrm>
-            <a:off x="970280" y="2194561"/>
-            <a:ext cx="1483360" cy="273050"/>
+            <a:off x="971550" y="2195761"/>
+            <a:ext cx="1480790" cy="273050"/>
           </a:xfrm>
           <a:prstGeom prst="rect">
             <a:avLst/>
@@ -7807,8 +10109,8 @@
         </p:nvSpPr>
         <p:spPr>
           <a:xfrm>
-            <a:off x="970280" y="2518411"/>
-            <a:ext cx="1483360" cy="482600"/>
+            <a:off x="971550" y="2519611"/>
+            <a:ext cx="1480790" cy="482600"/>
           </a:xfrm>
           <a:prstGeom prst="rect">
             <a:avLst/>
@@ -7851,8 +10153,8 @@
         </p:nvSpPr>
         <p:spPr>
           <a:xfrm>
-            <a:off x="970280" y="3051811"/>
-            <a:ext cx="1483360" cy="238760"/>
+            <a:off x="971550" y="3053011"/>
+            <a:ext cx="1480790" cy="238720"/>
           </a:xfrm>
           <a:prstGeom prst="rect">
             <a:avLst/>
@@ -7902,7 +10204,7 @@
         </p:blipFill>
         <p:spPr>
           <a:xfrm>
-            <a:off x="2661920" y="2691766"/>
+            <a:off x="2661890" y="2692946"/>
             <a:ext cx="254000" cy="76200"/>
           </a:xfrm>
           <a:prstGeom prst="rect">
@@ -7918,12 +10220,12 @@
         </p:nvSpPr>
         <p:spPr>
           <a:xfrm>
-            <a:off x="3020695" y="2040255"/>
-            <a:ext cx="1741170" cy="1379220"/>
+            <a:off x="3020665" y="2040186"/>
+            <a:ext cx="1741190" cy="1381720"/>
           </a:xfrm>
           <a:prstGeom prst="roundRect">
             <a:avLst>
-              <a:gd name="adj" fmla="val 7136"/>
+              <a:gd name="adj" fmla="val 7123"/>
             </a:avLst>
           </a:prstGeom>
           <a:solidFill>
@@ -7945,8 +10247,8 @@
         </p:nvSpPr>
         <p:spPr>
           <a:xfrm>
-            <a:off x="3175000" y="2194561"/>
-            <a:ext cx="1483360" cy="273050"/>
+            <a:off x="3176240" y="2195761"/>
+            <a:ext cx="1480840" cy="273050"/>
           </a:xfrm>
           <a:prstGeom prst="rect">
             <a:avLst/>
@@ -7989,8 +10291,8 @@
         </p:nvSpPr>
         <p:spPr>
           <a:xfrm>
-            <a:off x="3175000" y="2518411"/>
-            <a:ext cx="1483360" cy="482600"/>
+            <a:off x="3176240" y="2519611"/>
+            <a:ext cx="1480840" cy="482600"/>
           </a:xfrm>
           <a:prstGeom prst="rect">
             <a:avLst/>
@@ -8033,8 +10335,8 @@
         </p:nvSpPr>
         <p:spPr>
           <a:xfrm>
-            <a:off x="3175000" y="3051811"/>
-            <a:ext cx="1483360" cy="238760"/>
+            <a:off x="3176240" y="3053011"/>
+            <a:ext cx="1480840" cy="238720"/>
           </a:xfrm>
           <a:prstGeom prst="rect">
             <a:avLst/>
@@ -8084,7 +10386,7 @@
         </p:blipFill>
         <p:spPr>
           <a:xfrm>
-            <a:off x="4866640" y="2691766"/>
+            <a:off x="4866630" y="2692946"/>
             <a:ext cx="254000" cy="76200"/>
           </a:xfrm>
           <a:prstGeom prst="rect">
@@ -8100,12 +10402,12 @@
         </p:nvSpPr>
         <p:spPr>
           <a:xfrm>
-            <a:off x="5225415" y="2154555"/>
-            <a:ext cx="1741170" cy="1150620"/>
+            <a:off x="5225405" y="2154486"/>
+            <a:ext cx="1741140" cy="1153120"/>
           </a:xfrm>
           <a:prstGeom prst="roundRect">
             <a:avLst>
-              <a:gd name="adj" fmla="val 8554"/>
+              <a:gd name="adj" fmla="val 8536"/>
             </a:avLst>
           </a:prstGeom>
           <a:solidFill>
@@ -8127,8 +10429,8 @@
         </p:nvSpPr>
         <p:spPr>
           <a:xfrm>
-            <a:off x="5379720" y="2308861"/>
-            <a:ext cx="1483360" cy="273050"/>
+            <a:off x="5380980" y="2310061"/>
+            <a:ext cx="1480790" cy="273050"/>
           </a:xfrm>
           <a:prstGeom prst="rect">
             <a:avLst/>
@@ -8171,8 +10473,8 @@
         </p:nvSpPr>
         <p:spPr>
           <a:xfrm>
-            <a:off x="5379720" y="2632711"/>
-            <a:ext cx="1483360" cy="254000"/>
+            <a:off x="5380980" y="2633911"/>
+            <a:ext cx="1480790" cy="254000"/>
           </a:xfrm>
           <a:prstGeom prst="rect">
             <a:avLst/>
@@ -8215,8 +10517,8 @@
         </p:nvSpPr>
         <p:spPr>
           <a:xfrm>
-            <a:off x="5379720" y="2937511"/>
-            <a:ext cx="1483360" cy="238760"/>
+            <a:off x="5380980" y="2938711"/>
+            <a:ext cx="1480790" cy="238720"/>
           </a:xfrm>
           <a:prstGeom prst="rect">
             <a:avLst/>
@@ -8266,7 +10568,7 @@
         </p:blipFill>
         <p:spPr>
           <a:xfrm>
-            <a:off x="7071360" y="2691766"/>
+            <a:off x="7071320" y="2692946"/>
             <a:ext cx="254000" cy="76200"/>
           </a:xfrm>
           <a:prstGeom prst="rect">
@@ -8282,12 +10584,12 @@
         </p:nvSpPr>
         <p:spPr>
           <a:xfrm>
-            <a:off x="7430135" y="2154555"/>
-            <a:ext cx="1741170" cy="1150620"/>
+            <a:off x="7430095" y="2154486"/>
+            <a:ext cx="1741190" cy="1153120"/>
           </a:xfrm>
           <a:prstGeom prst="roundRect">
             <a:avLst>
-              <a:gd name="adj" fmla="val 8554"/>
+              <a:gd name="adj" fmla="val 8536"/>
             </a:avLst>
           </a:prstGeom>
           <a:solidFill>
@@ -8309,8 +10611,8 @@
         </p:nvSpPr>
         <p:spPr>
           <a:xfrm>
-            <a:off x="7584440" y="2308861"/>
-            <a:ext cx="1483360" cy="273050"/>
+            <a:off x="7585670" y="2310061"/>
+            <a:ext cx="1480840" cy="273050"/>
           </a:xfrm>
           <a:prstGeom prst="rect">
             <a:avLst/>
@@ -8353,8 +10655,8 @@
         </p:nvSpPr>
         <p:spPr>
           <a:xfrm>
-            <a:off x="7584440" y="2632711"/>
-            <a:ext cx="1483360" cy="254000"/>
+            <a:off x="7585670" y="2633911"/>
+            <a:ext cx="1480840" cy="254000"/>
           </a:xfrm>
           <a:prstGeom prst="rect">
             <a:avLst/>
@@ -8397,8 +10699,8 @@
         </p:nvSpPr>
         <p:spPr>
           <a:xfrm>
-            <a:off x="7584440" y="2937511"/>
-            <a:ext cx="1483360" cy="238760"/>
+            <a:off x="7585670" y="2938711"/>
+            <a:ext cx="1480840" cy="238720"/>
           </a:xfrm>
           <a:prstGeom prst="rect">
             <a:avLst/>
@@ -8448,7 +10750,7 @@
         </p:blipFill>
         <p:spPr>
           <a:xfrm>
-            <a:off x="9276080" y="2691766"/>
+            <a:off x="9276060" y="2692946"/>
             <a:ext cx="254000" cy="76200"/>
           </a:xfrm>
           <a:prstGeom prst="rect">
@@ -8464,12 +10766,12 @@
         </p:nvSpPr>
         <p:spPr>
           <a:xfrm>
-            <a:off x="9634855" y="2154555"/>
-            <a:ext cx="1741170" cy="1150620"/>
+            <a:off x="9634835" y="2154486"/>
+            <a:ext cx="1741190" cy="1153120"/>
           </a:xfrm>
           <a:prstGeom prst="roundRect">
             <a:avLst>
-              <a:gd name="adj" fmla="val 8554"/>
+              <a:gd name="adj" fmla="val 8536"/>
             </a:avLst>
           </a:prstGeom>
           <a:solidFill>
@@ -8491,8 +10793,8 @@
         </p:nvSpPr>
         <p:spPr>
           <a:xfrm>
-            <a:off x="9789160" y="2308861"/>
-            <a:ext cx="1483360" cy="273050"/>
+            <a:off x="9790410" y="2310061"/>
+            <a:ext cx="1480840" cy="273050"/>
           </a:xfrm>
           <a:prstGeom prst="rect">
             <a:avLst/>
@@ -8535,8 +10837,8 @@
         </p:nvSpPr>
         <p:spPr>
           <a:xfrm>
-            <a:off x="9789160" y="2632711"/>
-            <a:ext cx="1483360" cy="254000"/>
+            <a:off x="9790410" y="2633911"/>
+            <a:ext cx="1480840" cy="254000"/>
           </a:xfrm>
           <a:prstGeom prst="rect">
             <a:avLst/>
@@ -8579,8 +10881,8 @@
         </p:nvSpPr>
         <p:spPr>
           <a:xfrm>
-            <a:off x="9789160" y="2937511"/>
-            <a:ext cx="1483360" cy="238760"/>
+            <a:off x="9790410" y="2938711"/>
+            <a:ext cx="1480840" cy="238720"/>
           </a:xfrm>
           <a:prstGeom prst="rect">
             <a:avLst/>
@@ -8623,7 +10925,7 @@
         </p:nvSpPr>
         <p:spPr>
           <a:xfrm>
-            <a:off x="812800" y="3829050"/>
+            <a:off x="812800" y="3831481"/>
             <a:ext cx="10883392" cy="406400"/>
           </a:xfrm>
           <a:prstGeom prst="rect">
@@ -8722,7 +11024,7 @@
         <p:spPr>
           <a:xfrm>
             <a:off x="812800" y="812800"/>
-            <a:ext cx="10883392" cy="238760"/>
+            <a:ext cx="10883392" cy="238720"/>
           </a:xfrm>
           <a:prstGeom prst="rect">
             <a:avLst/>
@@ -8765,8 +11067,8 @@
         </p:nvSpPr>
         <p:spPr>
           <a:xfrm>
-            <a:off x="812800" y="1102361"/>
-            <a:ext cx="10883392" cy="553720"/>
+            <a:off x="812800" y="1102320"/>
+            <a:ext cx="10883392" cy="553690"/>
           </a:xfrm>
           <a:prstGeom prst="rect">
             <a:avLst/>
@@ -8816,7 +11118,7 @@
           </p:nvPr>
         </p:nvGraphicFramePr>
         <p:xfrm>
-          <a:off x="825500" y="1948182"/>
+          <a:off x="825500" y="1948111"/>
           <a:ext cx="10553700" cy="3302000"/>
         </p:xfrm>
         <a:graphic>
@@ -10557,7 +12859,7 @@
         <p:spPr>
           <a:xfrm>
             <a:off x="812800" y="812800"/>
-            <a:ext cx="10883392" cy="238760"/>
+            <a:ext cx="10883392" cy="238720"/>
           </a:xfrm>
           <a:prstGeom prst="rect">
             <a:avLst/>
@@ -10600,8 +12902,8 @@
         </p:nvSpPr>
         <p:spPr>
           <a:xfrm>
-            <a:off x="812800" y="1102361"/>
-            <a:ext cx="10883392" cy="553720"/>
+            <a:off x="812800" y="1102320"/>
+            <a:ext cx="10883392" cy="553690"/>
           </a:xfrm>
           <a:prstGeom prst="rect">
             <a:avLst/>
@@ -10644,7 +12946,7 @@
         </p:nvSpPr>
         <p:spPr>
           <a:xfrm>
-            <a:off x="812800" y="2353947"/>
+            <a:off x="812800" y="2355106"/>
             <a:ext cx="10566400" cy="0"/>
           </a:xfrm>
           <a:prstGeom prst="line">
@@ -10667,8 +12969,8 @@
         </p:nvSpPr>
         <p:spPr>
           <a:xfrm>
-            <a:off x="812800" y="2011682"/>
-            <a:ext cx="355600" cy="238760"/>
+            <a:off x="812800" y="2011611"/>
+            <a:ext cx="355600" cy="238720"/>
           </a:xfrm>
           <a:prstGeom prst="rect">
             <a:avLst/>
@@ -10711,8 +13013,8 @@
         </p:nvSpPr>
         <p:spPr>
           <a:xfrm>
-            <a:off x="1270000" y="1975486"/>
-            <a:ext cx="9711335" cy="311150"/>
+            <a:off x="1270000" y="1975396"/>
+            <a:ext cx="9711314" cy="311150"/>
           </a:xfrm>
           <a:prstGeom prst="rect">
             <a:avLst/>
@@ -10755,8 +13057,8 @@
         </p:nvSpPr>
         <p:spPr>
           <a:xfrm>
-            <a:off x="10850880" y="1960882"/>
-            <a:ext cx="528320" cy="314960"/>
+            <a:off x="10850860" y="1960811"/>
+            <a:ext cx="528340" cy="314920"/>
           </a:xfrm>
           <a:prstGeom prst="roundRect">
             <a:avLst>
@@ -10777,8 +13079,8 @@
         </p:nvSpPr>
         <p:spPr>
           <a:xfrm>
-            <a:off x="10977880" y="2011682"/>
-            <a:ext cx="325120" cy="238760"/>
+            <a:off x="10977860" y="2011611"/>
+            <a:ext cx="325140" cy="238720"/>
           </a:xfrm>
           <a:prstGeom prst="rect">
             <a:avLst/>
@@ -10821,7 +13123,7 @@
         </p:nvSpPr>
         <p:spPr>
           <a:xfrm>
-            <a:off x="812800" y="2826386"/>
+            <a:off x="812800" y="2828776"/>
             <a:ext cx="10566400" cy="0"/>
           </a:xfrm>
           <a:prstGeom prst="line">
@@ -10844,8 +13146,8 @@
         </p:nvSpPr>
         <p:spPr>
           <a:xfrm>
-            <a:off x="812800" y="2484121"/>
-            <a:ext cx="355600" cy="238760"/>
+            <a:off x="812800" y="2485281"/>
+            <a:ext cx="355600" cy="238720"/>
           </a:xfrm>
           <a:prstGeom prst="rect">
             <a:avLst/>
@@ -10888,8 +13190,8 @@
         </p:nvSpPr>
         <p:spPr>
           <a:xfrm>
-            <a:off x="1270000" y="2447925"/>
-            <a:ext cx="9711335" cy="311150"/>
+            <a:off x="1270000" y="2449066"/>
+            <a:ext cx="9711314" cy="311150"/>
           </a:xfrm>
           <a:prstGeom prst="rect">
             <a:avLst/>
@@ -10932,8 +13234,8 @@
         </p:nvSpPr>
         <p:spPr>
           <a:xfrm>
-            <a:off x="10850880" y="2433321"/>
-            <a:ext cx="528320" cy="314960"/>
+            <a:off x="10850860" y="2434481"/>
+            <a:ext cx="528340" cy="314920"/>
           </a:xfrm>
           <a:prstGeom prst="roundRect">
             <a:avLst>
@@ -10954,8 +13256,8 @@
         </p:nvSpPr>
         <p:spPr>
           <a:xfrm>
-            <a:off x="10977880" y="2484121"/>
-            <a:ext cx="325120" cy="238760"/>
+            <a:off x="10977860" y="2485281"/>
+            <a:ext cx="325140" cy="238720"/>
           </a:xfrm>
           <a:prstGeom prst="rect">
             <a:avLst/>
@@ -10998,7 +13300,7 @@
         </p:nvSpPr>
         <p:spPr>
           <a:xfrm>
-            <a:off x="812800" y="3298826"/>
+            <a:off x="812800" y="3302446"/>
             <a:ext cx="10566400" cy="0"/>
           </a:xfrm>
           <a:prstGeom prst="line">
@@ -11021,8 +13323,8 @@
         </p:nvSpPr>
         <p:spPr>
           <a:xfrm>
-            <a:off x="812800" y="2956561"/>
-            <a:ext cx="355600" cy="238760"/>
+            <a:off x="812800" y="2958951"/>
+            <a:ext cx="355600" cy="238720"/>
           </a:xfrm>
           <a:prstGeom prst="rect">
             <a:avLst/>
@@ -11065,8 +13367,8 @@
         </p:nvSpPr>
         <p:spPr>
           <a:xfrm>
-            <a:off x="1270000" y="2920364"/>
-            <a:ext cx="9711335" cy="311150"/>
+            <a:off x="1270000" y="2922736"/>
+            <a:ext cx="9711314" cy="311150"/>
           </a:xfrm>
           <a:prstGeom prst="rect">
             <a:avLst/>
@@ -11109,8 +13411,8 @@
         </p:nvSpPr>
         <p:spPr>
           <a:xfrm>
-            <a:off x="10850880" y="2905761"/>
-            <a:ext cx="528320" cy="314960"/>
+            <a:off x="10850860" y="2908151"/>
+            <a:ext cx="528340" cy="314920"/>
           </a:xfrm>
           <a:prstGeom prst="roundRect">
             <a:avLst>
@@ -11131,8 +13433,8 @@
         </p:nvSpPr>
         <p:spPr>
           <a:xfrm>
-            <a:off x="10977880" y="2956561"/>
-            <a:ext cx="325120" cy="238760"/>
+            <a:off x="10977860" y="2958951"/>
+            <a:ext cx="325140" cy="238720"/>
           </a:xfrm>
           <a:prstGeom prst="rect">
             <a:avLst/>
@@ -11175,7 +13477,7 @@
         </p:nvSpPr>
         <p:spPr>
           <a:xfrm>
-            <a:off x="812800" y="3771265"/>
+            <a:off x="812800" y="3776117"/>
             <a:ext cx="10566400" cy="0"/>
           </a:xfrm>
           <a:prstGeom prst="line">
@@ -11198,8 +13500,8 @@
         </p:nvSpPr>
         <p:spPr>
           <a:xfrm>
-            <a:off x="812800" y="3429000"/>
-            <a:ext cx="355600" cy="238760"/>
+            <a:off x="812800" y="3432621"/>
+            <a:ext cx="355600" cy="238720"/>
           </a:xfrm>
           <a:prstGeom prst="rect">
             <a:avLst/>
@@ -11242,8 +13544,8 @@
         </p:nvSpPr>
         <p:spPr>
           <a:xfrm>
-            <a:off x="1270000" y="3392807"/>
-            <a:ext cx="9146235" cy="311150"/>
+            <a:off x="1270000" y="3396407"/>
+            <a:ext cx="9146225" cy="311150"/>
           </a:xfrm>
           <a:prstGeom prst="rect">
             <a:avLst/>
@@ -11286,8 +13588,8 @@
         </p:nvSpPr>
         <p:spPr>
           <a:xfrm>
-            <a:off x="10302240" y="3378200"/>
-            <a:ext cx="1076960" cy="314960"/>
+            <a:off x="10302230" y="3381821"/>
+            <a:ext cx="1076970" cy="314920"/>
           </a:xfrm>
           <a:prstGeom prst="roundRect">
             <a:avLst>
@@ -11308,8 +13610,8 @@
         </p:nvSpPr>
         <p:spPr>
           <a:xfrm>
-            <a:off x="10429240" y="3429000"/>
-            <a:ext cx="873760" cy="238760"/>
+            <a:off x="10429230" y="3432621"/>
+            <a:ext cx="873770" cy="238720"/>
           </a:xfrm>
           <a:prstGeom prst="rect">
             <a:avLst/>
@@ -11352,7 +13654,7 @@
         </p:nvSpPr>
         <p:spPr>
           <a:xfrm>
-            <a:off x="812800" y="4243704"/>
+            <a:off x="812800" y="4249787"/>
             <a:ext cx="10566400" cy="0"/>
           </a:xfrm>
           <a:prstGeom prst="line">
@@ -11375,8 +13677,8 @@
         </p:nvSpPr>
         <p:spPr>
           <a:xfrm>
-            <a:off x="812800" y="3901439"/>
-            <a:ext cx="355600" cy="238760"/>
+            <a:off x="812800" y="3906292"/>
+            <a:ext cx="355600" cy="238720"/>
           </a:xfrm>
           <a:prstGeom prst="rect">
             <a:avLst/>
@@ -11419,8 +13721,8 @@
         </p:nvSpPr>
         <p:spPr>
           <a:xfrm>
-            <a:off x="1270000" y="3865246"/>
-            <a:ext cx="9899701" cy="311150"/>
+            <a:off x="1270000" y="3870077"/>
+            <a:ext cx="9899660" cy="311150"/>
           </a:xfrm>
           <a:prstGeom prst="rect">
             <a:avLst/>
@@ -11463,8 +13765,8 @@
         </p:nvSpPr>
         <p:spPr>
           <a:xfrm>
-            <a:off x="11033760" y="3850639"/>
-            <a:ext cx="345440" cy="314960"/>
+            <a:off x="11033720" y="3855492"/>
+            <a:ext cx="345480" cy="314920"/>
           </a:xfrm>
           <a:prstGeom prst="roundRect">
             <a:avLst>
@@ -11485,8 +13787,8 @@
         </p:nvSpPr>
         <p:spPr>
           <a:xfrm>
-            <a:off x="11160760" y="3901439"/>
-            <a:ext cx="142240" cy="238760"/>
+            <a:off x="11160720" y="3906292"/>
+            <a:ext cx="142280" cy="238720"/>
           </a:xfrm>
           <a:prstGeom prst="rect">
             <a:avLst/>
@@ -11529,8 +13831,8 @@
         </p:nvSpPr>
         <p:spPr>
           <a:xfrm>
-            <a:off x="812800" y="4373882"/>
-            <a:ext cx="355600" cy="238760"/>
+            <a:off x="812800" y="4379962"/>
+            <a:ext cx="355600" cy="238720"/>
           </a:xfrm>
           <a:prstGeom prst="rect">
             <a:avLst/>
@@ -11573,8 +13875,8 @@
         </p:nvSpPr>
         <p:spPr>
           <a:xfrm>
-            <a:off x="1270000" y="4337686"/>
-            <a:ext cx="9711335" cy="311150"/>
+            <a:off x="1270000" y="4343747"/>
+            <a:ext cx="9711314" cy="311150"/>
           </a:xfrm>
           <a:prstGeom prst="rect">
             <a:avLst/>
@@ -11617,8 +13919,8 @@
         </p:nvSpPr>
         <p:spPr>
           <a:xfrm>
-            <a:off x="10850880" y="4323082"/>
-            <a:ext cx="528320" cy="314960"/>
+            <a:off x="10850860" y="4329162"/>
+            <a:ext cx="528340" cy="314920"/>
           </a:xfrm>
           <a:prstGeom prst="roundRect">
             <a:avLst>
@@ -11639,8 +13941,8 @@
         </p:nvSpPr>
         <p:spPr>
           <a:xfrm>
-            <a:off x="10977880" y="4373882"/>
-            <a:ext cx="325120" cy="238760"/>
+            <a:off x="10977860" y="4379962"/>
+            <a:ext cx="325140" cy="238720"/>
           </a:xfrm>
           <a:prstGeom prst="rect">
             <a:avLst/>
@@ -11683,7 +13985,7 @@
         </p:nvSpPr>
         <p:spPr>
           <a:xfrm>
-            <a:off x="812800" y="4968239"/>
+            <a:off x="812800" y="4974282"/>
             <a:ext cx="10883392" cy="311150"/>
           </a:xfrm>
           <a:prstGeom prst="rect">
@@ -11771,7 +14073,7 @@
         <p:spPr>
           <a:xfrm>
             <a:off x="812800" y="812800"/>
-            <a:ext cx="10883392" cy="238760"/>
+            <a:ext cx="10883392" cy="238720"/>
           </a:xfrm>
           <a:prstGeom prst="rect">
             <a:avLst/>
@@ -11814,8 +14116,8 @@
         </p:nvSpPr>
         <p:spPr>
           <a:xfrm>
-            <a:off x="812800" y="1102361"/>
-            <a:ext cx="10883392" cy="553720"/>
+            <a:off x="812800" y="1102320"/>
+            <a:ext cx="10883392" cy="553690"/>
           </a:xfrm>
           <a:prstGeom prst="rect">
             <a:avLst/>
@@ -11858,8 +14160,8 @@
         </p:nvSpPr>
         <p:spPr>
           <a:xfrm>
-            <a:off x="812800" y="1833882"/>
-            <a:ext cx="4406860" cy="590550"/>
+            <a:off x="812800" y="1833811"/>
+            <a:ext cx="4406900" cy="590550"/>
           </a:xfrm>
           <a:prstGeom prst="roundRect">
             <a:avLst>
@@ -11880,8 +14182,8 @@
         </p:nvSpPr>
         <p:spPr>
           <a:xfrm>
-            <a:off x="1016000" y="1986282"/>
-            <a:ext cx="4120474" cy="311150"/>
+            <a:off x="1016000" y="1986211"/>
+            <a:ext cx="4120515" cy="311150"/>
           </a:xfrm>
           <a:prstGeom prst="rect">
             <a:avLst/>
@@ -11924,7 +14226,7 @@
         </p:nvSpPr>
         <p:spPr>
           <a:xfrm>
-            <a:off x="5422860" y="1986282"/>
+            <a:off x="5422900" y="1986211"/>
             <a:ext cx="3223649" cy="311150"/>
           </a:xfrm>
           <a:prstGeom prst="rect">
@@ -11975,7 +14277,7 @@
           </p:nvPr>
         </p:nvGraphicFramePr>
         <p:xfrm>
-          <a:off x="825500" y="2640332"/>
+          <a:off x="825500" y="2640261"/>
           <a:ext cx="10553700" cy="2063750"/>
         </p:xfrm>
         <a:graphic>
@@ -13038,7 +15340,7 @@
         </p:nvSpPr>
         <p:spPr>
           <a:xfrm>
-            <a:off x="812800" y="4907282"/>
+            <a:off x="812800" y="4907211"/>
             <a:ext cx="10883392" cy="406400"/>
           </a:xfrm>
           <a:prstGeom prst="rect">
@@ -13126,7 +15428,7 @@
         <p:spPr>
           <a:xfrm>
             <a:off x="812800" y="812800"/>
-            <a:ext cx="10883392" cy="238760"/>
+            <a:ext cx="10883392" cy="238720"/>
           </a:xfrm>
           <a:prstGeom prst="rect">
             <a:avLst/>
@@ -13169,8 +15471,8 @@
         </p:nvSpPr>
         <p:spPr>
           <a:xfrm>
-            <a:off x="812800" y="1102361"/>
-            <a:ext cx="10883392" cy="553720"/>
+            <a:off x="812800" y="1102320"/>
+            <a:ext cx="10883392" cy="553690"/>
           </a:xfrm>
           <a:prstGeom prst="rect">
             <a:avLst/>
@@ -13213,7 +15515,7 @@
         </p:nvSpPr>
         <p:spPr>
           <a:xfrm>
-            <a:off x="812800" y="1935482"/>
+            <a:off x="812800" y="1935411"/>
             <a:ext cx="5130800" cy="1739900"/>
           </a:xfrm>
           <a:prstGeom prst="roundRect">
@@ -13235,7 +15537,7 @@
         </p:nvSpPr>
         <p:spPr>
           <a:xfrm>
-            <a:off x="1016000" y="2138682"/>
+            <a:off x="1016000" y="2138611"/>
             <a:ext cx="4866132" cy="1358900"/>
           </a:xfrm>
           <a:prstGeom prst="rect">
@@ -13359,7 +15661,7 @@
         </p:nvSpPr>
         <p:spPr>
           <a:xfrm>
-            <a:off x="812800" y="3827782"/>
+            <a:off x="812800" y="3827711"/>
             <a:ext cx="5284724" cy="596900"/>
           </a:xfrm>
           <a:prstGeom prst="rect">
@@ -13403,12 +15705,12 @@
         </p:nvSpPr>
         <p:spPr>
           <a:xfrm>
-            <a:off x="6251575" y="1938657"/>
-            <a:ext cx="5124450" cy="1102360"/>
+            <a:off x="6251575" y="1938586"/>
+            <a:ext cx="5124450" cy="1104900"/>
           </a:xfrm>
           <a:prstGeom prst="roundRect">
             <a:avLst>
-              <a:gd name="adj" fmla="val 8929"/>
+              <a:gd name="adj" fmla="val 8908"/>
             </a:avLst>
           </a:prstGeom>
           <a:solidFill>
@@ -13430,8 +15732,8 @@
         </p:nvSpPr>
         <p:spPr>
           <a:xfrm>
-            <a:off x="6456680" y="2143761"/>
-            <a:ext cx="4855667" cy="355600"/>
+            <a:off x="6457950" y="2144961"/>
+            <a:ext cx="4853051" cy="355600"/>
           </a:xfrm>
           <a:prstGeom prst="rect">
             <a:avLst/>
@@ -13474,8 +15776,8 @@
         </p:nvSpPr>
         <p:spPr>
           <a:xfrm>
-            <a:off x="6456680" y="2550161"/>
-            <a:ext cx="4855667" cy="311150"/>
+            <a:off x="6457950" y="2551361"/>
+            <a:ext cx="4853051" cy="311150"/>
           </a:xfrm>
           <a:prstGeom prst="rect">
             <a:avLst/>
@@ -13518,12 +15820,12 @@
         </p:nvSpPr>
         <p:spPr>
           <a:xfrm>
-            <a:off x="6251575" y="3199764"/>
-            <a:ext cx="5124450" cy="2035810"/>
+            <a:off x="6251575" y="3202236"/>
+            <a:ext cx="5124450" cy="2038350"/>
           </a:xfrm>
           <a:prstGeom prst="roundRect">
             <a:avLst>
-              <a:gd name="adj" fmla="val 4835"/>
+              <a:gd name="adj" fmla="val 4829"/>
             </a:avLst>
           </a:prstGeom>
           <a:solidFill>
@@ -13545,8 +15847,8 @@
         </p:nvSpPr>
         <p:spPr>
           <a:xfrm>
-            <a:off x="6456680" y="3404871"/>
-            <a:ext cx="4855667" cy="355600"/>
+            <a:off x="6457950" y="3408611"/>
+            <a:ext cx="4853051" cy="355600"/>
           </a:xfrm>
           <a:prstGeom prst="rect">
             <a:avLst/>
@@ -13589,8 +15891,8 @@
         </p:nvSpPr>
         <p:spPr>
           <a:xfrm>
-            <a:off x="6456680" y="3811271"/>
-            <a:ext cx="4855667" cy="311150"/>
+            <a:off x="6457950" y="3815011"/>
+            <a:ext cx="4853051" cy="311150"/>
           </a:xfrm>
           <a:prstGeom prst="rect">
             <a:avLst/>
@@ -13633,8 +15935,8 @@
         </p:nvSpPr>
         <p:spPr>
           <a:xfrm>
-            <a:off x="6456680" y="4173221"/>
-            <a:ext cx="4855667" cy="882650"/>
+            <a:off x="6457950" y="4176961"/>
+            <a:ext cx="4853051" cy="882650"/>
           </a:xfrm>
           <a:prstGeom prst="rect">
             <a:avLst/>
@@ -13750,7 +16052,7 @@
         <p:spPr>
           <a:xfrm>
             <a:off x="812800" y="812800"/>
-            <a:ext cx="10883392" cy="238760"/>
+            <a:ext cx="10883392" cy="238720"/>
           </a:xfrm>
           <a:prstGeom prst="rect">
             <a:avLst/>
@@ -13793,8 +16095,8 @@
         </p:nvSpPr>
         <p:spPr>
           <a:xfrm>
-            <a:off x="812800" y="1102364"/>
-            <a:ext cx="10883392" cy="553720"/>
+            <a:off x="812800" y="1102320"/>
+            <a:ext cx="10883392" cy="553690"/>
           </a:xfrm>
           <a:prstGeom prst="rect">
             <a:avLst/>
@@ -13844,8 +16146,8 @@
           </p:nvPr>
         </p:nvGraphicFramePr>
         <p:xfrm>
-          <a:off x="825500" y="1948179"/>
-          <a:ext cx="10553700" cy="1930400"/>
+          <a:off x="825500" y="1948111"/>
+          <a:ext cx="10553700" cy="1930053"/>
         </p:xfrm>
         <a:graphic>
           <a:graphicData uri="http://schemas.openxmlformats.org/drawingml/2006/table">
@@ -13856,7 +16158,7 @@
                 <a:gridCol w="3377184"/>
                 <a:gridCol w="6121146"/>
               </a:tblGrid>
-              <a:tr h="386080">
+              <a:tr h="386011">
                 <a:tc>
                   <a:txBody>
                     <a:bodyPr/>
@@ -14071,7 +16373,7 @@
                   </a:tcPr>
                 </a:tc>
               </a:tr>
-              <a:tr h="386080">
+              <a:tr h="386011">
                 <a:tc>
                   <a:txBody>
                     <a:bodyPr/>
@@ -14277,7 +16579,7 @@
                   </a:tcPr>
                 </a:tc>
               </a:tr>
-              <a:tr h="386080">
+              <a:tr h="386011">
                 <a:tc>
                   <a:txBody>
                     <a:bodyPr/>
@@ -14492,7 +16794,7 @@
                   </a:tcPr>
                 </a:tc>
               </a:tr>
-              <a:tr h="386080">
+              <a:tr h="386011">
                 <a:tc>
                   <a:txBody>
                     <a:bodyPr/>
@@ -14698,7 +17000,7 @@
                   </a:tcPr>
                 </a:tc>
               </a:tr>
-              <a:tr h="386080">
+              <a:tr h="386011">
                 <a:tc>
                   <a:txBody>
                     <a:bodyPr/>

</xml_diff>